<commit_message>
Add adaptive tuning engine to pitch deck
</commit_message>
<xml_diff>
--- a/docs/pitch/NetraShield_MVP_Judge_Deck.pptx
+++ b/docs/pitch/NetraShield_MVP_Judge_Deck.pptx
@@ -2,25 +2,26 @@
 <file path=ppt/presentation.xml><?xml version="1.0" encoding="utf-8"?>
 <p:presentation xmlns:p="http://schemas.openxmlformats.org/presentationml/2006/main">
   <p:sldMasterIdLst>
-    <p:sldMasterId xmlns:r="http://schemas.openxmlformats.org/officeDocument/2006/relationships" id="2147483648" r:id="Rb39eab7ba0a9462b"/>
+    <p:sldMasterId xmlns:r="http://schemas.openxmlformats.org/officeDocument/2006/relationships" id="2147483648" r:id="Rcc88583298394afa"/>
   </p:sldMasterIdLst>
   <p:notesMasterIdLst>
-    <p:notesMasterId xmlns:r="http://schemas.openxmlformats.org/officeDocument/2006/relationships" r:id="R8aeb10dd17334e2e"/>
+    <p:notesMasterId xmlns:r="http://schemas.openxmlformats.org/officeDocument/2006/relationships" r:id="Rb19d099b0f4e4940"/>
   </p:notesMasterIdLst>
   <p:sldIdLst>
-    <p:sldId xmlns:r="http://schemas.openxmlformats.org/officeDocument/2006/relationships" id="256" r:id="R98d0cabb81f84279"/>
-    <p:sldId xmlns:r="http://schemas.openxmlformats.org/officeDocument/2006/relationships" id="257" r:id="R8cdb1b32777c4b03"/>
-    <p:sldId xmlns:r="http://schemas.openxmlformats.org/officeDocument/2006/relationships" id="258" r:id="R0b87e5e5aa5f405a"/>
-    <p:sldId xmlns:r="http://schemas.openxmlformats.org/officeDocument/2006/relationships" id="259" r:id="R37fa89684aab4962"/>
-    <p:sldId xmlns:r="http://schemas.openxmlformats.org/officeDocument/2006/relationships" id="260" r:id="Rea0565247b264604"/>
-    <p:sldId xmlns:r="http://schemas.openxmlformats.org/officeDocument/2006/relationships" id="261" r:id="R4e4d8cb1401b4e4d"/>
-    <p:sldId xmlns:r="http://schemas.openxmlformats.org/officeDocument/2006/relationships" id="262" r:id="R71e96fd5b7604743"/>
-    <p:sldId xmlns:r="http://schemas.openxmlformats.org/officeDocument/2006/relationships" id="263" r:id="R1ee32e156f014666"/>
-    <p:sldId xmlns:r="http://schemas.openxmlformats.org/officeDocument/2006/relationships" id="264" r:id="R817df6e0bae14807"/>
-    <p:sldId xmlns:r="http://schemas.openxmlformats.org/officeDocument/2006/relationships" id="265" r:id="Rcc4dd0d313444056"/>
-    <p:sldId xmlns:r="http://schemas.openxmlformats.org/officeDocument/2006/relationships" id="266" r:id="Raabbd9a6fba946e6"/>
-    <p:sldId xmlns:r="http://schemas.openxmlformats.org/officeDocument/2006/relationships" id="267" r:id="R3e58a2278c03496f"/>
-    <p:sldId xmlns:r="http://schemas.openxmlformats.org/officeDocument/2006/relationships" id="268" r:id="R6d8506318b974ad5"/>
+    <p:sldId xmlns:r="http://schemas.openxmlformats.org/officeDocument/2006/relationships" id="256" r:id="Rda949ec26aad448a"/>
+    <p:sldId xmlns:r="http://schemas.openxmlformats.org/officeDocument/2006/relationships" id="257" r:id="R34f946cb59984963"/>
+    <p:sldId xmlns:r="http://schemas.openxmlformats.org/officeDocument/2006/relationships" id="258" r:id="R83baf41dc256498a"/>
+    <p:sldId xmlns:r="http://schemas.openxmlformats.org/officeDocument/2006/relationships" id="259" r:id="Rb6edcbefdf504cb4"/>
+    <p:sldId xmlns:r="http://schemas.openxmlformats.org/officeDocument/2006/relationships" id="260" r:id="Rc985548a70cf4652"/>
+    <p:sldId xmlns:r="http://schemas.openxmlformats.org/officeDocument/2006/relationships" id="261" r:id="Re6becbbde4064ea8"/>
+    <p:sldId xmlns:r="http://schemas.openxmlformats.org/officeDocument/2006/relationships" id="262" r:id="R6656edbc463044fe"/>
+    <p:sldId xmlns:r="http://schemas.openxmlformats.org/officeDocument/2006/relationships" id="263" r:id="R93bfdb963a7a4b46"/>
+    <p:sldId xmlns:r="http://schemas.openxmlformats.org/officeDocument/2006/relationships" id="264" r:id="Raf4814aa767c49d0"/>
+    <p:sldId xmlns:r="http://schemas.openxmlformats.org/officeDocument/2006/relationships" id="265" r:id="Re261d3a6f4734818"/>
+    <p:sldId xmlns:r="http://schemas.openxmlformats.org/officeDocument/2006/relationships" id="266" r:id="Rdfb8d580d8a84cdb"/>
+    <p:sldId xmlns:r="http://schemas.openxmlformats.org/officeDocument/2006/relationships" id="267" r:id="R72509358734e4435"/>
+    <p:sldId xmlns:r="http://schemas.openxmlformats.org/officeDocument/2006/relationships" id="268" r:id="Ra862b714be034c01"/>
+    <p:sldId xmlns:r="http://schemas.openxmlformats.org/officeDocument/2006/relationships" id="269" r:id="R5fe1b1c8f71849eb"/>
   </p:sldIdLst>
   <p:sldSz cx="12192000" cy="6858000"/>
   <p:notesSz cx="6858000" cy="9144000"/>
@@ -793,6 +794,72 @@
 </p:notes>
 </file>
 
+<file path=ppt/notesSlides/notesSlide14.xml><?xml version="1.0" encoding="utf-8"?>
+<p:notes xmlns:p="http://schemas.openxmlformats.org/presentationml/2006/main">
+  <p:cSld>
+    <p:spTree>
+      <p:nvGrpSpPr>
+        <p:cNvPr id="1" name=""/>
+        <p:cNvGrpSpPr/>
+        <p:nvPr/>
+      </p:nvGrpSpPr>
+      <p:grpSpPr>
+        <a:xfrm xmlns:a="http://schemas.openxmlformats.org/drawingml/2006/main"/>
+      </p:grpSpPr>
+      <p:sp>
+        <p:nvSpPr>
+          <p:cNvPr id="2" name="Slide Image Placeholder 1"/>
+          <p:cNvSpPr>
+            <a:spLocks xmlns:a="http://schemas.openxmlformats.org/drawingml/2006/main" noGrp="1"/>
+          </p:cNvSpPr>
+          <p:nvPr>
+            <p:ph type="sldImg" idx="0"/>
+          </p:nvPr>
+        </p:nvSpPr>
+        <p:spPr/>
+      </p:sp>
+      <p:sp>
+        <p:nvSpPr>
+          <p:cNvPr id="3" name="Notes Placeholder 2"/>
+          <p:cNvSpPr>
+            <a:spLocks xmlns:a="http://schemas.openxmlformats.org/drawingml/2006/main" noGrp="1"/>
+          </p:cNvSpPr>
+          <p:nvPr>
+            <p:ph type="body" idx="1"/>
+          </p:nvPr>
+        </p:nvSpPr>
+        <p:spPr/>
+        <p:txBody>
+          <a:bodyPr xmlns:a="http://schemas.openxmlformats.org/drawingml/2006/main"/>
+          <a:lstStyle xmlns:a="http://schemas.openxmlformats.org/drawingml/2006/main"/>
+          <a:p xmlns:a="http://schemas.openxmlformats.org/drawingml/2006/main"/>
+        </p:txBody>
+      </p:sp>
+      <p:sp>
+        <p:nvSpPr>
+          <p:cNvPr id="4" name="Slide Number Placeholder 3"/>
+          <p:cNvSpPr>
+            <a:spLocks xmlns:a="http://schemas.openxmlformats.org/drawingml/2006/main" noGrp="1"/>
+          </p:cNvSpPr>
+          <p:nvPr>
+            <p:ph type="sldNum" idx="5"/>
+          </p:nvPr>
+        </p:nvSpPr>
+        <p:spPr/>
+        <p:txBody>
+          <a:bodyPr xmlns:a="http://schemas.openxmlformats.org/drawingml/2006/main"/>
+          <a:lstStyle xmlns:a="http://schemas.openxmlformats.org/drawingml/2006/main"/>
+          <a:p xmlns:a="http://schemas.openxmlformats.org/drawingml/2006/main"/>
+        </p:txBody>
+      </p:sp>
+    </p:spTree>
+  </p:cSld>
+  <p:clrMapOvr>
+    <a:masterClrMapping xmlns:a="http://schemas.openxmlformats.org/drawingml/2006/main"/>
+  </p:clrMapOvr>
+</p:notes>
+</file>
+
 <file path=ppt/notesSlides/notesSlide2.xml><?xml version="1.0" encoding="utf-8"?>
 <p:notes xmlns:p="http://schemas.openxmlformats.org/presentationml/2006/main">
   <p:cSld>
@@ -1319,6 +1386,23 @@
     <a:masterClrMapping xmlns:a="http://schemas.openxmlformats.org/drawingml/2006/main"/>
   </p:clrMapOvr>
 </p:notes>
+</file>
+
+<file path=ppt/slideLayouts/slideLayout1.xml><?xml version="1.0" encoding="utf-8"?>
+<p:sldLayout xmlns:p="http://schemas.openxmlformats.org/presentationml/2006/main">
+  <p:cSld>
+    <p:spTree>
+      <p:nvGrpSpPr>
+        <p:cNvPr id="1" name=""/>
+        <p:cNvGrpSpPr/>
+        <p:nvPr/>
+      </p:nvGrpSpPr>
+      <p:grpSpPr>
+        <a:xfrm xmlns:a="http://schemas.openxmlformats.org/drawingml/2006/main"/>
+      </p:grpSpPr>
+    </p:spTree>
+  </p:cSld>
+</p:sldLayout>
 </file>
 
 <file path=ppt/slideLayouts/slideLayout2.xml><?xml version="1.0" encoding="utf-8"?>
@@ -1359,7 +1443,8 @@
   </p:cSld>
   <p:clrMap bg1="lt1" tx1="dk1" bg2="lt2" tx2="dk2" accent1="accent1" accent2="accent2" accent3="accent3" accent4="accent4" accent5="accent5" accent6="accent6" hlink="hlink" folHlink="folHlink"/>
   <p:sldLayoutIdLst>
-    <p:sldLayoutId xmlns:r="http://schemas.openxmlformats.org/officeDocument/2006/relationships" id="2147483649" r:id="R3c237e6f13274a89"/>
+    <p:sldLayoutId xmlns:r="http://schemas.openxmlformats.org/officeDocument/2006/relationships" id="2147483648" r:id="Rd419e9baf0564d8a"/>
+    <p:sldLayoutId xmlns:r="http://schemas.openxmlformats.org/officeDocument/2006/relationships" id="2147483649" r:id="R07ef4b27eb8a47b1"/>
   </p:sldLayoutIdLst>
   <p:txStyles>
     <p:titleStyle>
@@ -1865,6 +1950,7 @@
           <a:lstStyle xmlns:a="http://schemas.openxmlformats.org/drawingml/2006/main"/>
           <a:p xmlns:a="http://schemas.openxmlformats.org/drawingml/2006/main">
             <a:pPr algn="l">
+              <a:buNone/>
               <a:defRPr sz="1350" b="1">
                 <a:solidFill>
                   <a:srgbClr val="0E9F8F"/>
@@ -1929,6 +2015,7 @@
           <a:lstStyle xmlns:a="http://schemas.openxmlformats.org/drawingml/2006/main"/>
           <a:p xmlns:a="http://schemas.openxmlformats.org/drawingml/2006/main">
             <a:pPr algn="l">
+              <a:buNone/>
               <a:defRPr sz="3150" b="1">
                 <a:solidFill>
                   <a:srgbClr val="FFFFFF"/>
@@ -1993,6 +2080,7 @@
           <a:lstStyle xmlns:a="http://schemas.openxmlformats.org/drawingml/2006/main"/>
           <a:p xmlns:a="http://schemas.openxmlformats.org/drawingml/2006/main">
             <a:pPr algn="l">
+              <a:buNone/>
               <a:defRPr sz="1275" b="0">
                 <a:solidFill>
                   <a:srgbClr val="C9D4E2"/>
@@ -2090,6 +2178,7 @@
           <a:lstStyle xmlns:a="http://schemas.openxmlformats.org/drawingml/2006/main"/>
           <a:p xmlns:a="http://schemas.openxmlformats.org/drawingml/2006/main">
             <a:pPr algn="ctr">
+              <a:buNone/>
               <a:defRPr sz="750" b="1">
                 <a:solidFill>
                   <a:srgbClr val="0E9F8F"/>
@@ -2187,6 +2276,7 @@
           <a:lstStyle xmlns:a="http://schemas.openxmlformats.org/drawingml/2006/main"/>
           <a:p xmlns:a="http://schemas.openxmlformats.org/drawingml/2006/main">
             <a:pPr algn="ctr">
+              <a:buNone/>
               <a:defRPr sz="750" b="1">
                 <a:solidFill>
                   <a:srgbClr val="2F6FED"/>
@@ -2284,6 +2374,7 @@
           <a:lstStyle xmlns:a="http://schemas.openxmlformats.org/drawingml/2006/main"/>
           <a:p xmlns:a="http://schemas.openxmlformats.org/drawingml/2006/main">
             <a:pPr algn="ctr">
+              <a:buNone/>
               <a:defRPr sz="750" b="1">
                 <a:solidFill>
                   <a:srgbClr val="F59E0B"/>
@@ -2381,6 +2472,7 @@
           <a:lstStyle xmlns:a="http://schemas.openxmlformats.org/drawingml/2006/main"/>
           <a:p xmlns:a="http://schemas.openxmlformats.org/drawingml/2006/main">
             <a:pPr algn="ctr">
+              <a:buNone/>
               <a:defRPr sz="750" b="1">
                 <a:solidFill>
                   <a:srgbClr val="22A06B"/>
@@ -2445,6 +2537,7 @@
           <a:lstStyle xmlns:a="http://schemas.openxmlformats.org/drawingml/2006/main"/>
           <a:p xmlns:a="http://schemas.openxmlformats.org/drawingml/2006/main">
             <a:pPr algn="l">
+              <a:buNone/>
               <a:defRPr sz="1050" b="1">
                 <a:solidFill>
                   <a:srgbClr val="D6E1F0"/>
@@ -2509,6 +2602,7 @@
           <a:lstStyle xmlns:a="http://schemas.openxmlformats.org/drawingml/2006/main"/>
           <a:p xmlns:a="http://schemas.openxmlformats.org/drawingml/2006/main">
             <a:pPr algn="l">
+              <a:buNone/>
               <a:defRPr sz="675" b="0">
                 <a:solidFill>
                   <a:srgbClr val="8793A3"/>
@@ -2573,6 +2667,7 @@
           <a:lstStyle xmlns:a="http://schemas.openxmlformats.org/drawingml/2006/main"/>
           <a:p xmlns:a="http://schemas.openxmlformats.org/drawingml/2006/main">
             <a:pPr algn="r">
+              <a:buNone/>
               <a:defRPr sz="750" b="1">
                 <a:solidFill>
                   <a:srgbClr val="66758A"/>
@@ -2694,6 +2789,7 @@
           <a:lstStyle xmlns:a="http://schemas.openxmlformats.org/drawingml/2006/main"/>
           <a:p xmlns:a="http://schemas.openxmlformats.org/drawingml/2006/main">
             <a:pPr algn="l">
+              <a:buNone/>
               <a:defRPr sz="900" b="1">
                 <a:solidFill>
                   <a:srgbClr val="0E9F8F"/>
@@ -2758,6 +2854,7 @@
           <a:lstStyle xmlns:a="http://schemas.openxmlformats.org/drawingml/2006/main"/>
           <a:p xmlns:a="http://schemas.openxmlformats.org/drawingml/2006/main">
             <a:pPr algn="l">
+              <a:buNone/>
               <a:defRPr sz="2400" b="1">
                 <a:solidFill>
                   <a:srgbClr val="111827"/>
@@ -2822,6 +2919,7 @@
           <a:lstStyle xmlns:a="http://schemas.openxmlformats.org/drawingml/2006/main"/>
           <a:p xmlns:a="http://schemas.openxmlformats.org/drawingml/2006/main">
             <a:pPr algn="l">
+              <a:buNone/>
               <a:defRPr sz="1125" b="0">
                 <a:solidFill>
                   <a:srgbClr val="66758A"/>
@@ -2952,6 +3050,7 @@
           <a:lstStyle xmlns:a="http://schemas.openxmlformats.org/drawingml/2006/main"/>
           <a:p xmlns:a="http://schemas.openxmlformats.org/drawingml/2006/main">
             <a:pPr algn="l">
+              <a:buNone/>
               <a:defRPr sz="1125" b="1">
                 <a:solidFill>
                   <a:srgbClr val="111827"/>
@@ -3016,6 +3115,7 @@
           <a:lstStyle xmlns:a="http://schemas.openxmlformats.org/drawingml/2006/main"/>
           <a:p xmlns:a="http://schemas.openxmlformats.org/drawingml/2006/main">
             <a:pPr algn="l">
+              <a:buNone/>
               <a:defRPr sz="900" b="0">
                 <a:solidFill>
                   <a:srgbClr val="526172"/>
@@ -3146,6 +3246,7 @@
           <a:lstStyle xmlns:a="http://schemas.openxmlformats.org/drawingml/2006/main"/>
           <a:p xmlns:a="http://schemas.openxmlformats.org/drawingml/2006/main">
             <a:pPr algn="l">
+              <a:buNone/>
               <a:defRPr sz="1125" b="1">
                 <a:solidFill>
                   <a:srgbClr val="111827"/>
@@ -3210,6 +3311,7 @@
           <a:lstStyle xmlns:a="http://schemas.openxmlformats.org/drawingml/2006/main"/>
           <a:p xmlns:a="http://schemas.openxmlformats.org/drawingml/2006/main">
             <a:pPr algn="l">
+              <a:buNone/>
               <a:defRPr sz="900" b="0">
                 <a:solidFill>
                   <a:srgbClr val="526172"/>
@@ -3340,6 +3442,7 @@
           <a:lstStyle xmlns:a="http://schemas.openxmlformats.org/drawingml/2006/main"/>
           <a:p xmlns:a="http://schemas.openxmlformats.org/drawingml/2006/main">
             <a:pPr algn="l">
+              <a:buNone/>
               <a:defRPr sz="1125" b="1">
                 <a:solidFill>
                   <a:srgbClr val="111827"/>
@@ -3404,6 +3507,7 @@
           <a:lstStyle xmlns:a="http://schemas.openxmlformats.org/drawingml/2006/main"/>
           <a:p xmlns:a="http://schemas.openxmlformats.org/drawingml/2006/main">
             <a:pPr algn="l">
+              <a:buNone/>
               <a:defRPr sz="900" b="0">
                 <a:solidFill>
                   <a:srgbClr val="526172"/>
@@ -3534,6 +3638,7 @@
           <a:lstStyle xmlns:a="http://schemas.openxmlformats.org/drawingml/2006/main"/>
           <a:p xmlns:a="http://schemas.openxmlformats.org/drawingml/2006/main">
             <a:pPr algn="l">
+              <a:buNone/>
               <a:defRPr sz="1125" b="1">
                 <a:solidFill>
                   <a:srgbClr val="111827"/>
@@ -3598,6 +3703,7 @@
           <a:lstStyle xmlns:a="http://schemas.openxmlformats.org/drawingml/2006/main"/>
           <a:p xmlns:a="http://schemas.openxmlformats.org/drawingml/2006/main">
             <a:pPr algn="l">
+              <a:buNone/>
               <a:defRPr sz="900" b="0">
                 <a:solidFill>
                   <a:srgbClr val="526172"/>
@@ -3695,6 +3801,7 @@
           <a:lstStyle xmlns:a="http://schemas.openxmlformats.org/drawingml/2006/main"/>
           <a:p xmlns:a="http://schemas.openxmlformats.org/drawingml/2006/main">
             <a:pPr algn="l">
+              <a:buNone/>
               <a:defRPr sz="1125" b="0">
                 <a:solidFill>
                   <a:srgbClr val="526172"/>
@@ -3792,6 +3899,7 @@
           <a:lstStyle xmlns:a="http://schemas.openxmlformats.org/drawingml/2006/main"/>
           <a:p xmlns:a="http://schemas.openxmlformats.org/drawingml/2006/main">
             <a:pPr algn="l">
+              <a:buNone/>
               <a:defRPr sz="1125" b="0">
                 <a:solidFill>
                   <a:srgbClr val="526172"/>
@@ -3889,6 +3997,7 @@
           <a:lstStyle xmlns:a="http://schemas.openxmlformats.org/drawingml/2006/main"/>
           <a:p xmlns:a="http://schemas.openxmlformats.org/drawingml/2006/main">
             <a:pPr algn="l">
+              <a:buNone/>
               <a:defRPr sz="1125" b="0">
                 <a:solidFill>
                   <a:srgbClr val="526172"/>
@@ -3953,6 +4062,7 @@
           <a:lstStyle xmlns:a="http://schemas.openxmlformats.org/drawingml/2006/main"/>
           <a:p xmlns:a="http://schemas.openxmlformats.org/drawingml/2006/main">
             <a:pPr algn="l">
+              <a:buNone/>
               <a:defRPr sz="675" b="0">
                 <a:solidFill>
                   <a:srgbClr val="8793A3"/>
@@ -4017,6 +4127,7 @@
           <a:lstStyle xmlns:a="http://schemas.openxmlformats.org/drawingml/2006/main"/>
           <a:p xmlns:a="http://schemas.openxmlformats.org/drawingml/2006/main">
             <a:pPr algn="r">
+              <a:buNone/>
               <a:defRPr sz="750" b="1">
                 <a:solidFill>
                   <a:srgbClr val="66758A"/>
@@ -4138,6 +4249,7 @@
           <a:lstStyle xmlns:a="http://schemas.openxmlformats.org/drawingml/2006/main"/>
           <a:p xmlns:a="http://schemas.openxmlformats.org/drawingml/2006/main">
             <a:pPr algn="l">
+              <a:buNone/>
               <a:defRPr sz="900" b="1">
                 <a:solidFill>
                   <a:srgbClr val="0E9F8F"/>
@@ -4202,6 +4314,7 @@
           <a:lstStyle xmlns:a="http://schemas.openxmlformats.org/drawingml/2006/main"/>
           <a:p xmlns:a="http://schemas.openxmlformats.org/drawingml/2006/main">
             <a:pPr algn="l">
+              <a:buNone/>
               <a:defRPr sz="2400" b="1">
                 <a:solidFill>
                   <a:srgbClr val="111827"/>
@@ -4266,6 +4379,7 @@
           <a:lstStyle xmlns:a="http://schemas.openxmlformats.org/drawingml/2006/main"/>
           <a:p xmlns:a="http://schemas.openxmlformats.org/drawingml/2006/main">
             <a:pPr algn="l">
+              <a:buNone/>
               <a:defRPr sz="1125" b="0">
                 <a:solidFill>
                   <a:srgbClr val="66758A"/>
@@ -4396,6 +4510,7 @@
           <a:lstStyle xmlns:a="http://schemas.openxmlformats.org/drawingml/2006/main"/>
           <a:p xmlns:a="http://schemas.openxmlformats.org/drawingml/2006/main">
             <a:pPr algn="l">
+              <a:buNone/>
               <a:defRPr sz="1125" b="1">
                 <a:solidFill>
                   <a:srgbClr val="111827"/>
@@ -4460,6 +4575,7 @@
           <a:lstStyle xmlns:a="http://schemas.openxmlformats.org/drawingml/2006/main"/>
           <a:p xmlns:a="http://schemas.openxmlformats.org/drawingml/2006/main">
             <a:pPr algn="l">
+              <a:buNone/>
               <a:defRPr sz="900" b="0">
                 <a:solidFill>
                   <a:srgbClr val="526172"/>
@@ -4590,6 +4706,7 @@
           <a:lstStyle xmlns:a="http://schemas.openxmlformats.org/drawingml/2006/main"/>
           <a:p xmlns:a="http://schemas.openxmlformats.org/drawingml/2006/main">
             <a:pPr algn="l">
+              <a:buNone/>
               <a:defRPr sz="1125" b="1">
                 <a:solidFill>
                   <a:srgbClr val="111827"/>
@@ -4654,6 +4771,7 @@
           <a:lstStyle xmlns:a="http://schemas.openxmlformats.org/drawingml/2006/main"/>
           <a:p xmlns:a="http://schemas.openxmlformats.org/drawingml/2006/main">
             <a:pPr algn="l">
+              <a:buNone/>
               <a:defRPr sz="900" b="0">
                 <a:solidFill>
                   <a:srgbClr val="526172"/>
@@ -4784,6 +4902,7 @@
           <a:lstStyle xmlns:a="http://schemas.openxmlformats.org/drawingml/2006/main"/>
           <a:p xmlns:a="http://schemas.openxmlformats.org/drawingml/2006/main">
             <a:pPr algn="l">
+              <a:buNone/>
               <a:defRPr sz="1125" b="1">
                 <a:solidFill>
                   <a:srgbClr val="111827"/>
@@ -4848,6 +4967,7 @@
           <a:lstStyle xmlns:a="http://schemas.openxmlformats.org/drawingml/2006/main"/>
           <a:p xmlns:a="http://schemas.openxmlformats.org/drawingml/2006/main">
             <a:pPr algn="l">
+              <a:buNone/>
               <a:defRPr sz="900" b="0">
                 <a:solidFill>
                   <a:srgbClr val="526172"/>
@@ -4978,6 +5098,7 @@
           <a:lstStyle xmlns:a="http://schemas.openxmlformats.org/drawingml/2006/main"/>
           <a:p xmlns:a="http://schemas.openxmlformats.org/drawingml/2006/main">
             <a:pPr algn="l">
+              <a:buNone/>
               <a:defRPr sz="1125" b="1">
                 <a:solidFill>
                   <a:srgbClr val="111827"/>
@@ -5042,6 +5163,7 @@
           <a:lstStyle xmlns:a="http://schemas.openxmlformats.org/drawingml/2006/main"/>
           <a:p xmlns:a="http://schemas.openxmlformats.org/drawingml/2006/main">
             <a:pPr algn="l">
+              <a:buNone/>
               <a:defRPr sz="900" b="0">
                 <a:solidFill>
                   <a:srgbClr val="526172"/>
@@ -5106,6 +5228,7 @@
           <a:lstStyle xmlns:a="http://schemas.openxmlformats.org/drawingml/2006/main"/>
           <a:p xmlns:a="http://schemas.openxmlformats.org/drawingml/2006/main">
             <a:pPr algn="ctr">
+              <a:buNone/>
               <a:defRPr sz="1500" b="1">
                 <a:solidFill>
                   <a:srgbClr val="111827"/>
@@ -5170,6 +5293,7 @@
           <a:lstStyle xmlns:a="http://schemas.openxmlformats.org/drawingml/2006/main"/>
           <a:p xmlns:a="http://schemas.openxmlformats.org/drawingml/2006/main">
             <a:pPr algn="l">
+              <a:buNone/>
               <a:defRPr sz="675" b="0">
                 <a:solidFill>
                   <a:srgbClr val="8793A3"/>
@@ -5234,6 +5358,7 @@
           <a:lstStyle xmlns:a="http://schemas.openxmlformats.org/drawingml/2006/main"/>
           <a:p xmlns:a="http://schemas.openxmlformats.org/drawingml/2006/main">
             <a:pPr algn="r">
+              <a:buNone/>
               <a:defRPr sz="750" b="1">
                 <a:solidFill>
                   <a:srgbClr val="66758A"/>
@@ -5355,6 +5480,7 @@
           <a:lstStyle xmlns:a="http://schemas.openxmlformats.org/drawingml/2006/main"/>
           <a:p xmlns:a="http://schemas.openxmlformats.org/drawingml/2006/main">
             <a:pPr algn="l">
+              <a:buNone/>
               <a:defRPr sz="900" b="1">
                 <a:solidFill>
                   <a:srgbClr val="0E9F8F"/>
@@ -5419,6 +5545,7 @@
           <a:lstStyle xmlns:a="http://schemas.openxmlformats.org/drawingml/2006/main"/>
           <a:p xmlns:a="http://schemas.openxmlformats.org/drawingml/2006/main">
             <a:pPr algn="l">
+              <a:buNone/>
               <a:defRPr sz="2400" b="1">
                 <a:solidFill>
                   <a:srgbClr val="111827"/>
@@ -5483,6 +5610,7 @@
           <a:lstStyle xmlns:a="http://schemas.openxmlformats.org/drawingml/2006/main"/>
           <a:p xmlns:a="http://schemas.openxmlformats.org/drawingml/2006/main">
             <a:pPr algn="l">
+              <a:buNone/>
               <a:defRPr sz="1125" b="0">
                 <a:solidFill>
                   <a:srgbClr val="66758A"/>
@@ -5580,6 +5708,7 @@
           <a:lstStyle xmlns:a="http://schemas.openxmlformats.org/drawingml/2006/main"/>
           <a:p xmlns:a="http://schemas.openxmlformats.org/drawingml/2006/main">
             <a:pPr algn="l">
+              <a:buNone/>
               <a:defRPr sz="2250" b="1">
                 <a:solidFill>
                   <a:srgbClr val="2F6FED"/>
@@ -5644,6 +5773,7 @@
           <a:lstStyle xmlns:a="http://schemas.openxmlformats.org/drawingml/2006/main"/>
           <a:p xmlns:a="http://schemas.openxmlformats.org/drawingml/2006/main">
             <a:pPr algn="l">
+              <a:buNone/>
               <a:defRPr sz="825" b="1">
                 <a:solidFill>
                   <a:srgbClr val="526172"/>
@@ -5741,6 +5871,7 @@
           <a:lstStyle xmlns:a="http://schemas.openxmlformats.org/drawingml/2006/main"/>
           <a:p xmlns:a="http://schemas.openxmlformats.org/drawingml/2006/main">
             <a:pPr algn="l">
+              <a:buNone/>
               <a:defRPr sz="2250" b="1">
                 <a:solidFill>
                   <a:srgbClr val="22A06B"/>
@@ -5805,6 +5936,7 @@
           <a:lstStyle xmlns:a="http://schemas.openxmlformats.org/drawingml/2006/main"/>
           <a:p xmlns:a="http://schemas.openxmlformats.org/drawingml/2006/main">
             <a:pPr algn="l">
+              <a:buNone/>
               <a:defRPr sz="825" b="1">
                 <a:solidFill>
                   <a:srgbClr val="526172"/>
@@ -5902,6 +6034,7 @@
           <a:lstStyle xmlns:a="http://schemas.openxmlformats.org/drawingml/2006/main"/>
           <a:p xmlns:a="http://schemas.openxmlformats.org/drawingml/2006/main">
             <a:pPr algn="l">
+              <a:buNone/>
               <a:defRPr sz="2250" b="1">
                 <a:solidFill>
                   <a:srgbClr val="F59E0B"/>
@@ -5966,6 +6099,7 @@
           <a:lstStyle xmlns:a="http://schemas.openxmlformats.org/drawingml/2006/main"/>
           <a:p xmlns:a="http://schemas.openxmlformats.org/drawingml/2006/main">
             <a:pPr algn="l">
+              <a:buNone/>
               <a:defRPr sz="825" b="1">
                 <a:solidFill>
                   <a:srgbClr val="526172"/>
@@ -6063,6 +6197,7 @@
           <a:lstStyle xmlns:a="http://schemas.openxmlformats.org/drawingml/2006/main"/>
           <a:p xmlns:a="http://schemas.openxmlformats.org/drawingml/2006/main">
             <a:pPr algn="l">
+              <a:buNone/>
               <a:defRPr sz="2250" b="1">
                 <a:solidFill>
                   <a:srgbClr val="0E9F8F"/>
@@ -6127,6 +6262,7 @@
           <a:lstStyle xmlns:a="http://schemas.openxmlformats.org/drawingml/2006/main"/>
           <a:p xmlns:a="http://schemas.openxmlformats.org/drawingml/2006/main">
             <a:pPr algn="l">
+              <a:buNone/>
               <a:defRPr sz="825" b="1">
                 <a:solidFill>
                   <a:srgbClr val="526172"/>
@@ -6257,6 +6393,7 @@
           <a:lstStyle xmlns:a="http://schemas.openxmlformats.org/drawingml/2006/main"/>
           <a:p xmlns:a="http://schemas.openxmlformats.org/drawingml/2006/main">
             <a:pPr algn="l">
+              <a:buNone/>
               <a:defRPr sz="1125" b="1">
                 <a:solidFill>
                   <a:srgbClr val="111827"/>
@@ -6321,6 +6458,7 @@
           <a:lstStyle xmlns:a="http://schemas.openxmlformats.org/drawingml/2006/main"/>
           <a:p xmlns:a="http://schemas.openxmlformats.org/drawingml/2006/main">
             <a:pPr algn="l">
+              <a:buNone/>
               <a:defRPr sz="900" b="0">
                 <a:solidFill>
                   <a:srgbClr val="526172"/>
@@ -6385,6 +6523,7 @@
           <a:lstStyle xmlns:a="http://schemas.openxmlformats.org/drawingml/2006/main"/>
           <a:p xmlns:a="http://schemas.openxmlformats.org/drawingml/2006/main">
             <a:pPr algn="l">
+              <a:buNone/>
               <a:defRPr sz="675" b="0">
                 <a:solidFill>
                   <a:srgbClr val="8793A3"/>
@@ -6449,6 +6588,7 @@
           <a:lstStyle xmlns:a="http://schemas.openxmlformats.org/drawingml/2006/main"/>
           <a:p xmlns:a="http://schemas.openxmlformats.org/drawingml/2006/main">
             <a:pPr algn="r">
+              <a:buNone/>
               <a:defRPr sz="750" b="1">
                 <a:solidFill>
                   <a:srgbClr val="66758A"/>
@@ -6570,6 +6710,7 @@
           <a:lstStyle xmlns:a="http://schemas.openxmlformats.org/drawingml/2006/main"/>
           <a:p xmlns:a="http://schemas.openxmlformats.org/drawingml/2006/main">
             <a:pPr algn="l">
+              <a:buNone/>
               <a:defRPr sz="900" b="1">
                 <a:solidFill>
                   <a:srgbClr val="0E9F8F"/>
@@ -6634,6 +6775,7 @@
           <a:lstStyle xmlns:a="http://schemas.openxmlformats.org/drawingml/2006/main"/>
           <a:p xmlns:a="http://schemas.openxmlformats.org/drawingml/2006/main">
             <a:pPr algn="l">
+              <a:buNone/>
               <a:defRPr sz="2400" b="1">
                 <a:solidFill>
                   <a:srgbClr val="111827"/>
@@ -6698,6 +6840,7 @@
           <a:lstStyle xmlns:a="http://schemas.openxmlformats.org/drawingml/2006/main"/>
           <a:p xmlns:a="http://schemas.openxmlformats.org/drawingml/2006/main">
             <a:pPr algn="l">
+              <a:buNone/>
               <a:defRPr sz="1125" b="0">
                 <a:solidFill>
                   <a:srgbClr val="66758A"/>
@@ -6795,6 +6938,7 @@
           <a:lstStyle xmlns:a="http://schemas.openxmlformats.org/drawingml/2006/main"/>
           <a:p xmlns:a="http://schemas.openxmlformats.org/drawingml/2006/main">
             <a:pPr algn="l">
+              <a:buNone/>
               <a:defRPr sz="1050" b="0">
                 <a:solidFill>
                   <a:srgbClr val="526172"/>
@@ -6892,6 +7036,7 @@
           <a:lstStyle xmlns:a="http://schemas.openxmlformats.org/drawingml/2006/main"/>
           <a:p xmlns:a="http://schemas.openxmlformats.org/drawingml/2006/main">
             <a:pPr algn="l">
+              <a:buNone/>
               <a:defRPr sz="1050" b="0">
                 <a:solidFill>
                   <a:srgbClr val="526172"/>
@@ -6989,6 +7134,7 @@
           <a:lstStyle xmlns:a="http://schemas.openxmlformats.org/drawingml/2006/main"/>
           <a:p xmlns:a="http://schemas.openxmlformats.org/drawingml/2006/main">
             <a:pPr algn="l">
+              <a:buNone/>
               <a:defRPr sz="1050" b="0">
                 <a:solidFill>
                   <a:srgbClr val="526172"/>
@@ -7086,6 +7232,7 @@
           <a:lstStyle xmlns:a="http://schemas.openxmlformats.org/drawingml/2006/main"/>
           <a:p xmlns:a="http://schemas.openxmlformats.org/drawingml/2006/main">
             <a:pPr algn="l">
+              <a:buNone/>
               <a:defRPr sz="1050" b="0">
                 <a:solidFill>
                   <a:srgbClr val="526172"/>
@@ -7183,6 +7330,7 @@
           <a:lstStyle xmlns:a="http://schemas.openxmlformats.org/drawingml/2006/main"/>
           <a:p xmlns:a="http://schemas.openxmlformats.org/drawingml/2006/main">
             <a:pPr algn="l">
+              <a:buNone/>
               <a:defRPr sz="1050" b="0">
                 <a:solidFill>
                   <a:srgbClr val="526172"/>
@@ -7280,6 +7428,7 @@
           <a:lstStyle xmlns:a="http://schemas.openxmlformats.org/drawingml/2006/main"/>
           <a:p xmlns:a="http://schemas.openxmlformats.org/drawingml/2006/main">
             <a:pPr algn="l">
+              <a:buNone/>
               <a:defRPr sz="1050" b="0">
                 <a:solidFill>
                   <a:srgbClr val="526172"/>
@@ -7344,6 +7493,7 @@
           <a:lstStyle xmlns:a="http://schemas.openxmlformats.org/drawingml/2006/main"/>
           <a:p xmlns:a="http://schemas.openxmlformats.org/drawingml/2006/main">
             <a:pPr algn="l">
+              <a:buNone/>
               <a:defRPr sz="675" b="0">
                 <a:solidFill>
                   <a:srgbClr val="8793A3"/>
@@ -7408,6 +7558,7 @@
           <a:lstStyle xmlns:a="http://schemas.openxmlformats.org/drawingml/2006/main"/>
           <a:p xmlns:a="http://schemas.openxmlformats.org/drawingml/2006/main">
             <a:pPr algn="r">
+              <a:buNone/>
               <a:defRPr sz="750" b="1">
                 <a:solidFill>
                   <a:srgbClr val="66758A"/>
@@ -7435,6 +7586,2164 @@
     <p:extLst>
       <p:ext uri="{BB962C8B-B14F-4D97-AF65-F5344CB8AC3E}">
         <p14:creationId xmlns:p14="http://schemas.microsoft.com/office/powerpoint/2010/main" val="1582313067"/>
+      </p:ext>
+    </p:extLst>
+  </p:cSld>
+</p:sld>
+</file>
+
+<file path=ppt/slides/slide14.xml><?xml version="1.0" encoding="utf-8"?>
+<p:sld xmlns:p="http://schemas.openxmlformats.org/presentationml/2006/main">
+  <p:cSld>
+    <p:spTree>
+      <p:nvGrpSpPr>
+        <p:cNvPr id="1" name=""/>
+        <p:cNvGrpSpPr/>
+        <p:nvPr/>
+      </p:nvGrpSpPr>
+      <p:grpSpPr>
+        <a:xfrm xmlns:a="http://schemas.openxmlformats.org/drawingml/2006/main"/>
+      </p:grpSpPr>
+      <p:sp>
+        <p:nvSpPr>
+          <p:cNvPr id="1" name="">
+            <a:extLst xmlns:a="http://schemas.openxmlformats.org/drawingml/2006/main">
+              <a:ext uri="{FF2B5EF4-FFF2-40B4-BE49-F238E27FC236}">
+                <a16:creationId xmlns:a16="http://schemas.microsoft.com/office/drawing/2014/main" id="{80537A22-27A9-4122-BBCB-333F07F32442}"/>
+              </a:ext>
+            </a:extLst>
+          </p:cNvPr>
+          <p:cNvSpPr>
+            <a:spLocks xmlns:a="http://schemas.openxmlformats.org/drawingml/2006/main" noGrp="1"/>
+          </p:cNvSpPr>
+          <p:nvPr/>
+        </p:nvSpPr>
+        <p:spPr>
+          <a:xfrm xmlns:a="http://schemas.openxmlformats.org/drawingml/2006/main">
+            <a:off x="0" y="0"/>
+            <a:ext cx="12192000" cy="6858000"/>
+          </a:xfrm>
+          <a:prstGeom xmlns:a="http://schemas.openxmlformats.org/drawingml/2006/main" prst="rect">
+            <a:avLst/>
+          </a:prstGeom>
+          <a:solidFill xmlns:a="http://schemas.openxmlformats.org/drawingml/2006/main">
+            <a:srgbClr val="F5F7FB"/>
+          </a:solidFill>
+          <a:ln xmlns:a="http://schemas.openxmlformats.org/drawingml/2006/main" w="0">
+            <a:solidFill>
+              <a:srgbClr val="000000">
+                <a:alpha val="0"/>
+              </a:srgbClr>
+            </a:solidFill>
+            <a:prstDash val="solid"/>
+          </a:ln>
+        </p:spPr>
+      </p:sp>
+      <p:sp>
+        <p:nvSpPr>
+          <p:cNvPr id="2" name="">
+            <a:extLst xmlns:a="http://schemas.openxmlformats.org/drawingml/2006/main">
+              <a:ext uri="{FF2B5EF4-FFF2-40B4-BE49-F238E27FC236}">
+                <a16:creationId xmlns:a16="http://schemas.microsoft.com/office/drawing/2014/main" id="{0DDEF795-0F40-4344-9E52-50AF351C9803}"/>
+              </a:ext>
+            </a:extLst>
+          </p:cNvPr>
+          <p:cNvSpPr>
+            <a:spLocks xmlns:a="http://schemas.openxmlformats.org/drawingml/2006/main" noGrp="1"/>
+          </p:cNvSpPr>
+          <p:nvPr/>
+        </p:nvSpPr>
+        <p:spPr>
+          <a:xfrm xmlns:a="http://schemas.openxmlformats.org/drawingml/2006/main">
+            <a:off x="552450" y="323850"/>
+            <a:ext cx="6858000" cy="209550"/>
+          </a:xfrm>
+          <a:prstGeom xmlns:a="http://schemas.openxmlformats.org/drawingml/2006/main" prst="rect">
+            <a:avLst/>
+          </a:prstGeom>
+          <a:solidFill xmlns:a="http://schemas.openxmlformats.org/drawingml/2006/main">
+            <a:srgbClr val="000000">
+              <a:alpha val="0"/>
+            </a:srgbClr>
+          </a:solidFill>
+          <a:ln xmlns:a="http://schemas.openxmlformats.org/drawingml/2006/main" w="0">
+            <a:solidFill>
+              <a:srgbClr val="000000">
+                <a:alpha val="0"/>
+              </a:srgbClr>
+            </a:solidFill>
+            <a:prstDash val="solid"/>
+          </a:ln>
+        </p:spPr>
+        <p:txBody>
+          <a:bodyPr xmlns:a="http://schemas.openxmlformats.org/drawingml/2006/main" lIns="0" tIns="0" rIns="0" bIns="0" anchor="t"/>
+          <a:lstStyle xmlns:a="http://schemas.openxmlformats.org/drawingml/2006/main"/>
+          <a:p xmlns:a="http://schemas.openxmlformats.org/drawingml/2006/main">
+            <a:pPr algn="l">
+              <a:defRPr sz="900" b="1">
+                <a:solidFill>
+                  <a:srgbClr val="0E9F8F"/>
+                </a:solidFill>
+                <a:latin typeface="Aptos"/>
+                <a:ea typeface="Aptos"/>
+                <a:cs typeface="Aptos"/>
+              </a:defRPr>
+            </a:pPr>
+            <a:r>
+              <a:rPr sz="900" b="1">
+                <a:solidFill>
+                  <a:srgbClr val="0E9F8F"/>
+                </a:solidFill>
+                <a:latin typeface="Aptos"/>
+                <a:ea typeface="Aptos"/>
+                <a:cs typeface="Aptos"/>
+              </a:rPr>
+              <a:t>CORE BRAIN ARCHITECTURE</a:t>
+            </a:r>
+          </a:p>
+        </p:txBody>
+      </p:sp>
+      <p:sp>
+        <p:nvSpPr>
+          <p:cNvPr id="3" name="">
+            <a:extLst xmlns:a="http://schemas.openxmlformats.org/drawingml/2006/main">
+              <a:ext uri="{FF2B5EF4-FFF2-40B4-BE49-F238E27FC236}">
+                <a16:creationId xmlns:a16="http://schemas.microsoft.com/office/drawing/2014/main" id="{C3258C6F-E595-4C31-8B8D-A185CE5BA722}"/>
+              </a:ext>
+            </a:extLst>
+          </p:cNvPr>
+          <p:cNvSpPr>
+            <a:spLocks xmlns:a="http://schemas.openxmlformats.org/drawingml/2006/main" noGrp="1"/>
+          </p:cNvSpPr>
+          <p:nvPr/>
+        </p:nvSpPr>
+        <p:spPr>
+          <a:xfrm xmlns:a="http://schemas.openxmlformats.org/drawingml/2006/main">
+            <a:off x="533400" y="609600"/>
+            <a:ext cx="8858250" cy="571500"/>
+          </a:xfrm>
+          <a:prstGeom xmlns:a="http://schemas.openxmlformats.org/drawingml/2006/main" prst="rect">
+            <a:avLst/>
+          </a:prstGeom>
+          <a:solidFill xmlns:a="http://schemas.openxmlformats.org/drawingml/2006/main">
+            <a:srgbClr val="000000">
+              <a:alpha val="0"/>
+            </a:srgbClr>
+          </a:solidFill>
+          <a:ln xmlns:a="http://schemas.openxmlformats.org/drawingml/2006/main" w="0">
+            <a:solidFill>
+              <a:srgbClr val="000000">
+                <a:alpha val="0"/>
+              </a:srgbClr>
+            </a:solidFill>
+            <a:prstDash val="solid"/>
+          </a:ln>
+        </p:spPr>
+        <p:txBody>
+          <a:bodyPr xmlns:a="http://schemas.openxmlformats.org/drawingml/2006/main" lIns="0" tIns="0" rIns="0" bIns="0" anchor="t"/>
+          <a:lstStyle xmlns:a="http://schemas.openxmlformats.org/drawingml/2006/main"/>
+          <a:p xmlns:a="http://schemas.openxmlformats.org/drawingml/2006/main">
+            <a:pPr algn="l">
+              <a:defRPr sz="2400" b="1">
+                <a:solidFill>
+                  <a:srgbClr val="111827"/>
+                </a:solidFill>
+                <a:latin typeface="Aptos Display"/>
+                <a:ea typeface="Aptos Display"/>
+                <a:cs typeface="Aptos Display"/>
+              </a:defRPr>
+            </a:pPr>
+            <a:r>
+              <a:rPr sz="2400" b="1">
+                <a:solidFill>
+                  <a:srgbClr val="111827"/>
+                </a:solidFill>
+                <a:latin typeface="Aptos Display"/>
+                <a:ea typeface="Aptos Display"/>
+                <a:cs typeface="Aptos Display"/>
+              </a:rPr>
+              <a:t>Adaptive tuning engine that gets more reliable with more data</a:t>
+            </a:r>
+          </a:p>
+        </p:txBody>
+      </p:sp>
+      <p:sp>
+        <p:nvSpPr>
+          <p:cNvPr id="4" name="">
+            <a:extLst xmlns:a="http://schemas.openxmlformats.org/drawingml/2006/main">
+              <a:ext uri="{FF2B5EF4-FFF2-40B4-BE49-F238E27FC236}">
+                <a16:creationId xmlns:a16="http://schemas.microsoft.com/office/drawing/2014/main" id="{5B028874-D51C-4357-BF20-5D6D1A32F82E}"/>
+              </a:ext>
+            </a:extLst>
+          </p:cNvPr>
+          <p:cNvSpPr>
+            <a:spLocks xmlns:a="http://schemas.openxmlformats.org/drawingml/2006/main" noGrp="1"/>
+          </p:cNvSpPr>
+          <p:nvPr/>
+        </p:nvSpPr>
+        <p:spPr>
+          <a:xfrm xmlns:a="http://schemas.openxmlformats.org/drawingml/2006/main">
+            <a:off x="552450" y="1200150"/>
+            <a:ext cx="8382000" cy="419100"/>
+          </a:xfrm>
+          <a:prstGeom xmlns:a="http://schemas.openxmlformats.org/drawingml/2006/main" prst="rect">
+            <a:avLst/>
+          </a:prstGeom>
+          <a:solidFill xmlns:a="http://schemas.openxmlformats.org/drawingml/2006/main">
+            <a:srgbClr val="000000">
+              <a:alpha val="0"/>
+            </a:srgbClr>
+          </a:solidFill>
+          <a:ln xmlns:a="http://schemas.openxmlformats.org/drawingml/2006/main" w="0">
+            <a:solidFill>
+              <a:srgbClr val="000000">
+                <a:alpha val="0"/>
+              </a:srgbClr>
+            </a:solidFill>
+            <a:prstDash val="solid"/>
+          </a:ln>
+        </p:spPr>
+        <p:txBody>
+          <a:bodyPr xmlns:a="http://schemas.openxmlformats.org/drawingml/2006/main" lIns="0" tIns="0" rIns="0" bIns="0" anchor="t"/>
+          <a:lstStyle xmlns:a="http://schemas.openxmlformats.org/drawingml/2006/main"/>
+          <a:p xmlns:a="http://schemas.openxmlformats.org/drawingml/2006/main">
+            <a:pPr algn="l">
+              <a:defRPr sz="1125" b="0">
+                <a:solidFill>
+                  <a:srgbClr val="66758A"/>
+                </a:solidFill>
+                <a:latin typeface="Aptos"/>
+                <a:ea typeface="Aptos"/>
+                <a:cs typeface="Aptos"/>
+              </a:defRPr>
+            </a:pPr>
+            <a:r>
+              <a:rPr sz="1125" b="0">
+                <a:solidFill>
+                  <a:srgbClr val="66758A"/>
+                </a:solidFill>
+                <a:latin typeface="Aptos"/>
+                <a:ea typeface="Aptos"/>
+                <a:cs typeface="Aptos"/>
+              </a:rPr>
+              <a:t>This is not risky model fine-tuning in the MVP. It is a closed-loop SOC tuning memory that learns from alert history, analyst feedback, grouping outcomes, and cache performance.</a:t>
+            </a:r>
+          </a:p>
+        </p:txBody>
+      </p:sp>
+      <p:sp>
+        <p:nvSpPr>
+          <p:cNvPr id="5" name="">
+            <a:extLst xmlns:a="http://schemas.openxmlformats.org/drawingml/2006/main">
+              <a:ext uri="{FF2B5EF4-FFF2-40B4-BE49-F238E27FC236}">
+                <a16:creationId xmlns:a16="http://schemas.microsoft.com/office/drawing/2014/main" id="{607807D6-4C24-4A93-B37F-F433E94DD5A5}"/>
+              </a:ext>
+            </a:extLst>
+          </p:cNvPr>
+          <p:cNvSpPr>
+            <a:spLocks xmlns:a="http://schemas.openxmlformats.org/drawingml/2006/main" noGrp="1"/>
+          </p:cNvSpPr>
+          <p:nvPr/>
+        </p:nvSpPr>
+        <p:spPr>
+          <a:xfrm xmlns:a="http://schemas.openxmlformats.org/drawingml/2006/main">
+            <a:off x="552450" y="1695450"/>
+            <a:ext cx="1952625" cy="1257300"/>
+          </a:xfrm>
+          <a:prstGeom xmlns:a="http://schemas.openxmlformats.org/drawingml/2006/main" prst="rect">
+            <a:avLst/>
+          </a:prstGeom>
+          <a:solidFill xmlns:a="http://schemas.openxmlformats.org/drawingml/2006/main">
+            <a:srgbClr val="FFFFFF"/>
+          </a:solidFill>
+          <a:ln xmlns:a="http://schemas.openxmlformats.org/drawingml/2006/main" w="9525">
+            <a:solidFill>
+              <a:srgbClr val="D7DFEA"/>
+            </a:solidFill>
+            <a:prstDash val="solid"/>
+          </a:ln>
+        </p:spPr>
+      </p:sp>
+      <p:sp>
+        <p:nvSpPr>
+          <p:cNvPr id="6" name="">
+            <a:extLst xmlns:a="http://schemas.openxmlformats.org/drawingml/2006/main">
+              <a:ext uri="{FF2B5EF4-FFF2-40B4-BE49-F238E27FC236}">
+                <a16:creationId xmlns:a16="http://schemas.microsoft.com/office/drawing/2014/main" id="{47CD9C27-99C0-49DE-8E8F-2BF89BEE8A0F}"/>
+              </a:ext>
+            </a:extLst>
+          </p:cNvPr>
+          <p:cNvSpPr>
+            <a:spLocks xmlns:a="http://schemas.openxmlformats.org/drawingml/2006/main" noGrp="1"/>
+          </p:cNvSpPr>
+          <p:nvPr/>
+        </p:nvSpPr>
+        <p:spPr>
+          <a:xfrm xmlns:a="http://schemas.openxmlformats.org/drawingml/2006/main">
+            <a:off x="552450" y="1695450"/>
+            <a:ext cx="1952625" cy="66675"/>
+          </a:xfrm>
+          <a:prstGeom xmlns:a="http://schemas.openxmlformats.org/drawingml/2006/main" prst="rect">
+            <a:avLst/>
+          </a:prstGeom>
+          <a:solidFill xmlns:a="http://schemas.openxmlformats.org/drawingml/2006/main">
+            <a:srgbClr val="2F6FED"/>
+          </a:solidFill>
+          <a:ln xmlns:a="http://schemas.openxmlformats.org/drawingml/2006/main" w="0">
+            <a:solidFill>
+              <a:srgbClr val="2F6FED"/>
+            </a:solidFill>
+            <a:prstDash val="solid"/>
+          </a:ln>
+        </p:spPr>
+      </p:sp>
+      <p:sp>
+        <p:nvSpPr>
+          <p:cNvPr id="7" name="">
+            <a:extLst xmlns:a="http://schemas.openxmlformats.org/drawingml/2006/main">
+              <a:ext uri="{FF2B5EF4-FFF2-40B4-BE49-F238E27FC236}">
+                <a16:creationId xmlns:a16="http://schemas.microsoft.com/office/drawing/2014/main" id="{748B0505-26C7-42C5-90A8-94B9CDE6423E}"/>
+              </a:ext>
+            </a:extLst>
+          </p:cNvPr>
+          <p:cNvSpPr>
+            <a:spLocks xmlns:a="http://schemas.openxmlformats.org/drawingml/2006/main" noGrp="1"/>
+          </p:cNvSpPr>
+          <p:nvPr/>
+        </p:nvSpPr>
+        <p:spPr>
+          <a:xfrm xmlns:a="http://schemas.openxmlformats.org/drawingml/2006/main">
+            <a:off x="723900" y="1885950"/>
+            <a:ext cx="1609725" cy="228600"/>
+          </a:xfrm>
+          <a:prstGeom xmlns:a="http://schemas.openxmlformats.org/drawingml/2006/main" prst="rect">
+            <a:avLst/>
+          </a:prstGeom>
+          <a:solidFill xmlns:a="http://schemas.openxmlformats.org/drawingml/2006/main">
+            <a:srgbClr val="000000">
+              <a:alpha val="0"/>
+            </a:srgbClr>
+          </a:solidFill>
+          <a:ln xmlns:a="http://schemas.openxmlformats.org/drawingml/2006/main" w="0">
+            <a:solidFill>
+              <a:srgbClr val="000000">
+                <a:alpha val="0"/>
+              </a:srgbClr>
+            </a:solidFill>
+            <a:prstDash val="solid"/>
+          </a:ln>
+        </p:spPr>
+        <p:txBody>
+          <a:bodyPr xmlns:a="http://schemas.openxmlformats.org/drawingml/2006/main" lIns="0" tIns="0" rIns="0" bIns="0" anchor="t"/>
+          <a:lstStyle xmlns:a="http://schemas.openxmlformats.org/drawingml/2006/main"/>
+          <a:p xmlns:a="http://schemas.openxmlformats.org/drawingml/2006/main">
+            <a:pPr algn="l">
+              <a:defRPr sz="1050" b="1">
+                <a:solidFill>
+                  <a:srgbClr val="111827"/>
+                </a:solidFill>
+                <a:latin typeface="Aptos"/>
+                <a:ea typeface="Aptos"/>
+                <a:cs typeface="Aptos"/>
+              </a:defRPr>
+            </a:pPr>
+            <a:r>
+              <a:rPr sz="1050" b="1">
+                <a:solidFill>
+                  <a:srgbClr val="111827"/>
+                </a:solidFill>
+                <a:latin typeface="Aptos"/>
+                <a:ea typeface="Aptos"/>
+                <a:cs typeface="Aptos"/>
+              </a:rPr>
+              <a:t>1. Normalized Alert</a:t>
+            </a:r>
+          </a:p>
+        </p:txBody>
+      </p:sp>
+      <p:sp>
+        <p:nvSpPr>
+          <p:cNvPr id="8" name="">
+            <a:extLst xmlns:a="http://schemas.openxmlformats.org/drawingml/2006/main">
+              <a:ext uri="{FF2B5EF4-FFF2-40B4-BE49-F238E27FC236}">
+                <a16:creationId xmlns:a16="http://schemas.microsoft.com/office/drawing/2014/main" id="{74BD2E8E-9F69-434B-B622-60C94AB47FCC}"/>
+              </a:ext>
+            </a:extLst>
+          </p:cNvPr>
+          <p:cNvSpPr>
+            <a:spLocks xmlns:a="http://schemas.openxmlformats.org/drawingml/2006/main" noGrp="1"/>
+          </p:cNvSpPr>
+          <p:nvPr/>
+        </p:nvSpPr>
+        <p:spPr>
+          <a:xfrm xmlns:a="http://schemas.openxmlformats.org/drawingml/2006/main">
+            <a:off x="723900" y="2209800"/>
+            <a:ext cx="1609725" cy="628650"/>
+          </a:xfrm>
+          <a:prstGeom xmlns:a="http://schemas.openxmlformats.org/drawingml/2006/main" prst="rect">
+            <a:avLst/>
+          </a:prstGeom>
+          <a:solidFill xmlns:a="http://schemas.openxmlformats.org/drawingml/2006/main">
+            <a:srgbClr val="000000">
+              <a:alpha val="0"/>
+            </a:srgbClr>
+          </a:solidFill>
+          <a:ln xmlns:a="http://schemas.openxmlformats.org/drawingml/2006/main" w="0">
+            <a:solidFill>
+              <a:srgbClr val="000000">
+                <a:alpha val="0"/>
+              </a:srgbClr>
+            </a:solidFill>
+            <a:prstDash val="solid"/>
+          </a:ln>
+        </p:spPr>
+        <p:txBody>
+          <a:bodyPr xmlns:a="http://schemas.openxmlformats.org/drawingml/2006/main" lIns="0" tIns="0" rIns="0" bIns="0" anchor="t"/>
+          <a:lstStyle xmlns:a="http://schemas.openxmlformats.org/drawingml/2006/main"/>
+          <a:p xmlns:a="http://schemas.openxmlformats.org/drawingml/2006/main">
+            <a:pPr algn="l">
+              <a:defRPr sz="825" b="0">
+                <a:solidFill>
+                  <a:srgbClr val="526172"/>
+                </a:solidFill>
+                <a:latin typeface="Aptos"/>
+                <a:ea typeface="Aptos"/>
+                <a:cs typeface="Aptos"/>
+              </a:defRPr>
+            </a:pPr>
+            <a:r>
+              <a:rPr sz="825" b="0">
+                <a:solidFill>
+                  <a:srgbClr val="526172"/>
+                </a:solidFill>
+                <a:latin typeface="Aptos"/>
+                <a:ea typeface="Aptos"/>
+                <a:cs typeface="Aptos"/>
+              </a:rPr>
+              <a:t>Rule, severity, asset, user, source IP, MITRE, raw evidence summary, and timestamp become a stable SIEM-agnostic object.</a:t>
+            </a:r>
+          </a:p>
+        </p:txBody>
+      </p:sp>
+      <p:sp>
+        <p:nvSpPr>
+          <p:cNvPr id="9" name="">
+            <a:extLst xmlns:a="http://schemas.openxmlformats.org/drawingml/2006/main">
+              <a:ext uri="{FF2B5EF4-FFF2-40B4-BE49-F238E27FC236}">
+                <a16:creationId xmlns:a16="http://schemas.microsoft.com/office/drawing/2014/main" id="{E7648ED9-E708-444C-AB94-65AF4E09CB98}"/>
+              </a:ext>
+            </a:extLst>
+          </p:cNvPr>
+          <p:cNvSpPr>
+            <a:spLocks xmlns:a="http://schemas.openxmlformats.org/drawingml/2006/main" noGrp="1"/>
+          </p:cNvSpPr>
+          <p:nvPr/>
+        </p:nvSpPr>
+        <p:spPr>
+          <a:xfrm xmlns:a="http://schemas.openxmlformats.org/drawingml/2006/main">
+            <a:off x="2571750" y="2266950"/>
+            <a:ext cx="552450" cy="66675"/>
+          </a:xfrm>
+          <a:prstGeom xmlns:a="http://schemas.openxmlformats.org/drawingml/2006/main" prst="rect">
+            <a:avLst/>
+          </a:prstGeom>
+          <a:solidFill xmlns:a="http://schemas.openxmlformats.org/drawingml/2006/main">
+            <a:srgbClr val="B8C4D6"/>
+          </a:solidFill>
+          <a:ln xmlns:a="http://schemas.openxmlformats.org/drawingml/2006/main" w="0">
+            <a:solidFill>
+              <a:srgbClr val="B8C4D6"/>
+            </a:solidFill>
+            <a:prstDash val="solid"/>
+          </a:ln>
+        </p:spPr>
+      </p:sp>
+      <p:sp>
+        <p:nvSpPr>
+          <p:cNvPr id="10" name="">
+            <a:extLst xmlns:a="http://schemas.openxmlformats.org/drawingml/2006/main">
+              <a:ext uri="{FF2B5EF4-FFF2-40B4-BE49-F238E27FC236}">
+                <a16:creationId xmlns:a16="http://schemas.microsoft.com/office/drawing/2014/main" id="{0F15683E-356F-42A0-9394-3D99B2550957}"/>
+              </a:ext>
+            </a:extLst>
+          </p:cNvPr>
+          <p:cNvSpPr>
+            <a:spLocks xmlns:a="http://schemas.openxmlformats.org/drawingml/2006/main" noGrp="1"/>
+          </p:cNvSpPr>
+          <p:nvPr/>
+        </p:nvSpPr>
+        <p:spPr>
+          <a:xfrm xmlns:a="http://schemas.openxmlformats.org/drawingml/2006/main">
+            <a:off x="3105150" y="2190750"/>
+            <a:ext cx="171450" cy="209550"/>
+          </a:xfrm>
+          <a:prstGeom xmlns:a="http://schemas.openxmlformats.org/drawingml/2006/main" prst="triangle">
+            <a:avLst/>
+          </a:prstGeom>
+          <a:solidFill xmlns:a="http://schemas.openxmlformats.org/drawingml/2006/main">
+            <a:srgbClr val="B8C4D6"/>
+          </a:solidFill>
+          <a:ln xmlns:a="http://schemas.openxmlformats.org/drawingml/2006/main" w="0">
+            <a:solidFill>
+              <a:srgbClr val="B8C4D6"/>
+            </a:solidFill>
+            <a:prstDash val="solid"/>
+          </a:ln>
+        </p:spPr>
+      </p:sp>
+      <p:sp>
+        <p:nvSpPr>
+          <p:cNvPr id="11" name="">
+            <a:extLst xmlns:a="http://schemas.openxmlformats.org/drawingml/2006/main">
+              <a:ext uri="{FF2B5EF4-FFF2-40B4-BE49-F238E27FC236}">
+                <a16:creationId xmlns:a16="http://schemas.microsoft.com/office/drawing/2014/main" id="{7FB8CB89-A57B-4322-BAA8-3704C592BD03}"/>
+              </a:ext>
+            </a:extLst>
+          </p:cNvPr>
+          <p:cNvSpPr>
+            <a:spLocks xmlns:a="http://schemas.openxmlformats.org/drawingml/2006/main" noGrp="1"/>
+          </p:cNvSpPr>
+          <p:nvPr/>
+        </p:nvSpPr>
+        <p:spPr>
+          <a:xfrm xmlns:a="http://schemas.openxmlformats.org/drawingml/2006/main">
+            <a:off x="3190875" y="1695450"/>
+            <a:ext cx="1952625" cy="1257300"/>
+          </a:xfrm>
+          <a:prstGeom xmlns:a="http://schemas.openxmlformats.org/drawingml/2006/main" prst="rect">
+            <a:avLst/>
+          </a:prstGeom>
+          <a:solidFill xmlns:a="http://schemas.openxmlformats.org/drawingml/2006/main">
+            <a:srgbClr val="FFFFFF"/>
+          </a:solidFill>
+          <a:ln xmlns:a="http://schemas.openxmlformats.org/drawingml/2006/main" w="9525">
+            <a:solidFill>
+              <a:srgbClr val="D7DFEA"/>
+            </a:solidFill>
+            <a:prstDash val="solid"/>
+          </a:ln>
+        </p:spPr>
+      </p:sp>
+      <p:sp>
+        <p:nvSpPr>
+          <p:cNvPr id="12" name="">
+            <a:extLst xmlns:a="http://schemas.openxmlformats.org/drawingml/2006/main">
+              <a:ext uri="{FF2B5EF4-FFF2-40B4-BE49-F238E27FC236}">
+                <a16:creationId xmlns:a16="http://schemas.microsoft.com/office/drawing/2014/main" id="{3F6B80FD-F3C5-4A46-A0CE-B710D2EB61BA}"/>
+              </a:ext>
+            </a:extLst>
+          </p:cNvPr>
+          <p:cNvSpPr>
+            <a:spLocks xmlns:a="http://schemas.openxmlformats.org/drawingml/2006/main" noGrp="1"/>
+          </p:cNvSpPr>
+          <p:nvPr/>
+        </p:nvSpPr>
+        <p:spPr>
+          <a:xfrm xmlns:a="http://schemas.openxmlformats.org/drawingml/2006/main">
+            <a:off x="3190875" y="1695450"/>
+            <a:ext cx="1952625" cy="66675"/>
+          </a:xfrm>
+          <a:prstGeom xmlns:a="http://schemas.openxmlformats.org/drawingml/2006/main" prst="rect">
+            <a:avLst/>
+          </a:prstGeom>
+          <a:solidFill xmlns:a="http://schemas.openxmlformats.org/drawingml/2006/main">
+            <a:srgbClr val="0E9F8F"/>
+          </a:solidFill>
+          <a:ln xmlns:a="http://schemas.openxmlformats.org/drawingml/2006/main" w="0">
+            <a:solidFill>
+              <a:srgbClr val="0E9F8F"/>
+            </a:solidFill>
+            <a:prstDash val="solid"/>
+          </a:ln>
+        </p:spPr>
+      </p:sp>
+      <p:sp>
+        <p:nvSpPr>
+          <p:cNvPr id="13" name="">
+            <a:extLst xmlns:a="http://schemas.openxmlformats.org/drawingml/2006/main">
+              <a:ext uri="{FF2B5EF4-FFF2-40B4-BE49-F238E27FC236}">
+                <a16:creationId xmlns:a16="http://schemas.microsoft.com/office/drawing/2014/main" id="{2908B484-1C18-4664-B4DF-6BE3FA6E7DAB}"/>
+              </a:ext>
+            </a:extLst>
+          </p:cNvPr>
+          <p:cNvSpPr>
+            <a:spLocks xmlns:a="http://schemas.openxmlformats.org/drawingml/2006/main" noGrp="1"/>
+          </p:cNvSpPr>
+          <p:nvPr/>
+        </p:nvSpPr>
+        <p:spPr>
+          <a:xfrm xmlns:a="http://schemas.openxmlformats.org/drawingml/2006/main">
+            <a:off x="3362325" y="1885950"/>
+            <a:ext cx="1609725" cy="228600"/>
+          </a:xfrm>
+          <a:prstGeom xmlns:a="http://schemas.openxmlformats.org/drawingml/2006/main" prst="rect">
+            <a:avLst/>
+          </a:prstGeom>
+          <a:solidFill xmlns:a="http://schemas.openxmlformats.org/drawingml/2006/main">
+            <a:srgbClr val="000000">
+              <a:alpha val="0"/>
+            </a:srgbClr>
+          </a:solidFill>
+          <a:ln xmlns:a="http://schemas.openxmlformats.org/drawingml/2006/main" w="0">
+            <a:solidFill>
+              <a:srgbClr val="000000">
+                <a:alpha val="0"/>
+              </a:srgbClr>
+            </a:solidFill>
+            <a:prstDash val="solid"/>
+          </a:ln>
+        </p:spPr>
+        <p:txBody>
+          <a:bodyPr xmlns:a="http://schemas.openxmlformats.org/drawingml/2006/main" lIns="0" tIns="0" rIns="0" bIns="0" anchor="t"/>
+          <a:lstStyle xmlns:a="http://schemas.openxmlformats.org/drawingml/2006/main"/>
+          <a:p xmlns:a="http://schemas.openxmlformats.org/drawingml/2006/main">
+            <a:pPr algn="l">
+              <a:defRPr sz="1050" b="1">
+                <a:solidFill>
+                  <a:srgbClr val="111827"/>
+                </a:solidFill>
+                <a:latin typeface="Aptos"/>
+                <a:ea typeface="Aptos"/>
+                <a:cs typeface="Aptos"/>
+              </a:defRPr>
+            </a:pPr>
+            <a:r>
+              <a:rPr sz="1050" b="1">
+                <a:solidFill>
+                  <a:srgbClr val="111827"/>
+                </a:solidFill>
+                <a:latin typeface="Aptos"/>
+                <a:ea typeface="Aptos"/>
+                <a:cs typeface="Aptos"/>
+              </a:rPr>
+              <a:t>2. Feature Memory</a:t>
+            </a:r>
+          </a:p>
+        </p:txBody>
+      </p:sp>
+      <p:sp>
+        <p:nvSpPr>
+          <p:cNvPr id="14" name="">
+            <a:extLst xmlns:a="http://schemas.openxmlformats.org/drawingml/2006/main">
+              <a:ext uri="{FF2B5EF4-FFF2-40B4-BE49-F238E27FC236}">
+                <a16:creationId xmlns:a16="http://schemas.microsoft.com/office/drawing/2014/main" id="{4016D035-EA7B-42EB-9A34-455EBE83D5F4}"/>
+              </a:ext>
+            </a:extLst>
+          </p:cNvPr>
+          <p:cNvSpPr>
+            <a:spLocks xmlns:a="http://schemas.openxmlformats.org/drawingml/2006/main" noGrp="1"/>
+          </p:cNvSpPr>
+          <p:nvPr/>
+        </p:nvSpPr>
+        <p:spPr>
+          <a:xfrm xmlns:a="http://schemas.openxmlformats.org/drawingml/2006/main">
+            <a:off x="3362325" y="2209800"/>
+            <a:ext cx="1609725" cy="628650"/>
+          </a:xfrm>
+          <a:prstGeom xmlns:a="http://schemas.openxmlformats.org/drawingml/2006/main" prst="rect">
+            <a:avLst/>
+          </a:prstGeom>
+          <a:solidFill xmlns:a="http://schemas.openxmlformats.org/drawingml/2006/main">
+            <a:srgbClr val="000000">
+              <a:alpha val="0"/>
+            </a:srgbClr>
+          </a:solidFill>
+          <a:ln xmlns:a="http://schemas.openxmlformats.org/drawingml/2006/main" w="0">
+            <a:solidFill>
+              <a:srgbClr val="000000">
+                <a:alpha val="0"/>
+              </a:srgbClr>
+            </a:solidFill>
+            <a:prstDash val="solid"/>
+          </a:ln>
+        </p:spPr>
+        <p:txBody>
+          <a:bodyPr xmlns:a="http://schemas.openxmlformats.org/drawingml/2006/main" lIns="0" tIns="0" rIns="0" bIns="0" anchor="t"/>
+          <a:lstStyle xmlns:a="http://schemas.openxmlformats.org/drawingml/2006/main"/>
+          <a:p xmlns:a="http://schemas.openxmlformats.org/drawingml/2006/main">
+            <a:pPr algn="l">
+              <a:defRPr sz="825" b="0">
+                <a:solidFill>
+                  <a:srgbClr val="526172"/>
+                </a:solidFill>
+                <a:latin typeface="Aptos"/>
+                <a:ea typeface="Aptos"/>
+                <a:cs typeface="Aptos"/>
+              </a:defRPr>
+            </a:pPr>
+            <a:r>
+              <a:rPr sz="825" b="0">
+                <a:solidFill>
+                  <a:srgbClr val="526172"/>
+                </a:solidFill>
+                <a:latin typeface="Aptos"/>
+                <a:ea typeface="Aptos"/>
+                <a:cs typeface="Aptos"/>
+              </a:rPr>
+              <a:t>Entity frequency, asset criticality, rule history, repeated source patterns, local IOC hits, and previous verdicts.</a:t>
+            </a:r>
+          </a:p>
+        </p:txBody>
+      </p:sp>
+      <p:sp>
+        <p:nvSpPr>
+          <p:cNvPr id="15" name="">
+            <a:extLst xmlns:a="http://schemas.openxmlformats.org/drawingml/2006/main">
+              <a:ext uri="{FF2B5EF4-FFF2-40B4-BE49-F238E27FC236}">
+                <a16:creationId xmlns:a16="http://schemas.microsoft.com/office/drawing/2014/main" id="{88FD96D6-87B5-48CD-8441-B015C4D6D32A}"/>
+              </a:ext>
+            </a:extLst>
+          </p:cNvPr>
+          <p:cNvSpPr>
+            <a:spLocks xmlns:a="http://schemas.openxmlformats.org/drawingml/2006/main" noGrp="1"/>
+          </p:cNvSpPr>
+          <p:nvPr/>
+        </p:nvSpPr>
+        <p:spPr>
+          <a:xfrm xmlns:a="http://schemas.openxmlformats.org/drawingml/2006/main">
+            <a:off x="5219700" y="2266950"/>
+            <a:ext cx="552450" cy="66675"/>
+          </a:xfrm>
+          <a:prstGeom xmlns:a="http://schemas.openxmlformats.org/drawingml/2006/main" prst="rect">
+            <a:avLst/>
+          </a:prstGeom>
+          <a:solidFill xmlns:a="http://schemas.openxmlformats.org/drawingml/2006/main">
+            <a:srgbClr val="B8C4D6"/>
+          </a:solidFill>
+          <a:ln xmlns:a="http://schemas.openxmlformats.org/drawingml/2006/main" w="0">
+            <a:solidFill>
+              <a:srgbClr val="B8C4D6"/>
+            </a:solidFill>
+            <a:prstDash val="solid"/>
+          </a:ln>
+        </p:spPr>
+      </p:sp>
+      <p:sp>
+        <p:nvSpPr>
+          <p:cNvPr id="16" name="">
+            <a:extLst xmlns:a="http://schemas.openxmlformats.org/drawingml/2006/main">
+              <a:ext uri="{FF2B5EF4-FFF2-40B4-BE49-F238E27FC236}">
+                <a16:creationId xmlns:a16="http://schemas.microsoft.com/office/drawing/2014/main" id="{264F1651-3310-44DD-8328-54576A99D4A5}"/>
+              </a:ext>
+            </a:extLst>
+          </p:cNvPr>
+          <p:cNvSpPr>
+            <a:spLocks xmlns:a="http://schemas.openxmlformats.org/drawingml/2006/main" noGrp="1"/>
+          </p:cNvSpPr>
+          <p:nvPr/>
+        </p:nvSpPr>
+        <p:spPr>
+          <a:xfrm xmlns:a="http://schemas.openxmlformats.org/drawingml/2006/main">
+            <a:off x="5753100" y="2190750"/>
+            <a:ext cx="171450" cy="209550"/>
+          </a:xfrm>
+          <a:prstGeom xmlns:a="http://schemas.openxmlformats.org/drawingml/2006/main" prst="triangle">
+            <a:avLst/>
+          </a:prstGeom>
+          <a:solidFill xmlns:a="http://schemas.openxmlformats.org/drawingml/2006/main">
+            <a:srgbClr val="B8C4D6"/>
+          </a:solidFill>
+          <a:ln xmlns:a="http://schemas.openxmlformats.org/drawingml/2006/main" w="0">
+            <a:solidFill>
+              <a:srgbClr val="B8C4D6"/>
+            </a:solidFill>
+            <a:prstDash val="solid"/>
+          </a:ln>
+        </p:spPr>
+      </p:sp>
+      <p:sp>
+        <p:nvSpPr>
+          <p:cNvPr id="17" name="">
+            <a:extLst xmlns:a="http://schemas.openxmlformats.org/drawingml/2006/main">
+              <a:ext uri="{FF2B5EF4-FFF2-40B4-BE49-F238E27FC236}">
+                <a16:creationId xmlns:a16="http://schemas.microsoft.com/office/drawing/2014/main" id="{D35E935F-D5B5-4431-B1B8-C31A5A5A1D07}"/>
+              </a:ext>
+            </a:extLst>
+          </p:cNvPr>
+          <p:cNvSpPr>
+            <a:spLocks xmlns:a="http://schemas.openxmlformats.org/drawingml/2006/main" noGrp="1"/>
+          </p:cNvSpPr>
+          <p:nvPr/>
+        </p:nvSpPr>
+        <p:spPr>
+          <a:xfrm xmlns:a="http://schemas.openxmlformats.org/drawingml/2006/main">
+            <a:off x="5829300" y="1695450"/>
+            <a:ext cx="1952625" cy="1257300"/>
+          </a:xfrm>
+          <a:prstGeom xmlns:a="http://schemas.openxmlformats.org/drawingml/2006/main" prst="rect">
+            <a:avLst/>
+          </a:prstGeom>
+          <a:solidFill xmlns:a="http://schemas.openxmlformats.org/drawingml/2006/main">
+            <a:srgbClr val="FFFFFF"/>
+          </a:solidFill>
+          <a:ln xmlns:a="http://schemas.openxmlformats.org/drawingml/2006/main" w="9525">
+            <a:solidFill>
+              <a:srgbClr val="D7DFEA"/>
+            </a:solidFill>
+            <a:prstDash val="solid"/>
+          </a:ln>
+        </p:spPr>
+      </p:sp>
+      <p:sp>
+        <p:nvSpPr>
+          <p:cNvPr id="18" name="">
+            <a:extLst xmlns:a="http://schemas.openxmlformats.org/drawingml/2006/main">
+              <a:ext uri="{FF2B5EF4-FFF2-40B4-BE49-F238E27FC236}">
+                <a16:creationId xmlns:a16="http://schemas.microsoft.com/office/drawing/2014/main" id="{7E032418-21A5-4063-AF24-70C1497C6FD7}"/>
+              </a:ext>
+            </a:extLst>
+          </p:cNvPr>
+          <p:cNvSpPr>
+            <a:spLocks xmlns:a="http://schemas.openxmlformats.org/drawingml/2006/main" noGrp="1"/>
+          </p:cNvSpPr>
+          <p:nvPr/>
+        </p:nvSpPr>
+        <p:spPr>
+          <a:xfrm xmlns:a="http://schemas.openxmlformats.org/drawingml/2006/main">
+            <a:off x="5829300" y="1695450"/>
+            <a:ext cx="1952625" cy="66675"/>
+          </a:xfrm>
+          <a:prstGeom xmlns:a="http://schemas.openxmlformats.org/drawingml/2006/main" prst="rect">
+            <a:avLst/>
+          </a:prstGeom>
+          <a:solidFill xmlns:a="http://schemas.openxmlformats.org/drawingml/2006/main">
+            <a:srgbClr val="F59E0B"/>
+          </a:solidFill>
+          <a:ln xmlns:a="http://schemas.openxmlformats.org/drawingml/2006/main" w="0">
+            <a:solidFill>
+              <a:srgbClr val="F59E0B"/>
+            </a:solidFill>
+            <a:prstDash val="solid"/>
+          </a:ln>
+        </p:spPr>
+      </p:sp>
+      <p:sp>
+        <p:nvSpPr>
+          <p:cNvPr id="19" name="">
+            <a:extLst xmlns:a="http://schemas.openxmlformats.org/drawingml/2006/main">
+              <a:ext uri="{FF2B5EF4-FFF2-40B4-BE49-F238E27FC236}">
+                <a16:creationId xmlns:a16="http://schemas.microsoft.com/office/drawing/2014/main" id="{8DBCC8B9-9CF3-40D5-AE0B-E3B432D6C0AA}"/>
+              </a:ext>
+            </a:extLst>
+          </p:cNvPr>
+          <p:cNvSpPr>
+            <a:spLocks xmlns:a="http://schemas.openxmlformats.org/drawingml/2006/main" noGrp="1"/>
+          </p:cNvSpPr>
+          <p:nvPr/>
+        </p:nvSpPr>
+        <p:spPr>
+          <a:xfrm xmlns:a="http://schemas.openxmlformats.org/drawingml/2006/main">
+            <a:off x="6000750" y="1885950"/>
+            <a:ext cx="1609725" cy="228600"/>
+          </a:xfrm>
+          <a:prstGeom xmlns:a="http://schemas.openxmlformats.org/drawingml/2006/main" prst="rect">
+            <a:avLst/>
+          </a:prstGeom>
+          <a:solidFill xmlns:a="http://schemas.openxmlformats.org/drawingml/2006/main">
+            <a:srgbClr val="000000">
+              <a:alpha val="0"/>
+            </a:srgbClr>
+          </a:solidFill>
+          <a:ln xmlns:a="http://schemas.openxmlformats.org/drawingml/2006/main" w="0">
+            <a:solidFill>
+              <a:srgbClr val="000000">
+                <a:alpha val="0"/>
+              </a:srgbClr>
+            </a:solidFill>
+            <a:prstDash val="solid"/>
+          </a:ln>
+        </p:spPr>
+        <p:txBody>
+          <a:bodyPr xmlns:a="http://schemas.openxmlformats.org/drawingml/2006/main" lIns="0" tIns="0" rIns="0" bIns="0" anchor="t"/>
+          <a:lstStyle xmlns:a="http://schemas.openxmlformats.org/drawingml/2006/main"/>
+          <a:p xmlns:a="http://schemas.openxmlformats.org/drawingml/2006/main">
+            <a:pPr algn="l">
+              <a:defRPr sz="1050" b="1">
+                <a:solidFill>
+                  <a:srgbClr val="111827"/>
+                </a:solidFill>
+                <a:latin typeface="Aptos"/>
+                <a:ea typeface="Aptos"/>
+                <a:cs typeface="Aptos"/>
+              </a:defRPr>
+            </a:pPr>
+            <a:r>
+              <a:rPr sz="1050" b="1">
+                <a:solidFill>
+                  <a:srgbClr val="111827"/>
+                </a:solidFill>
+                <a:latin typeface="Aptos"/>
+                <a:ea typeface="Aptos"/>
+                <a:cs typeface="Aptos"/>
+              </a:rPr>
+              <a:t>3. Grouping Brain</a:t>
+            </a:r>
+          </a:p>
+        </p:txBody>
+      </p:sp>
+      <p:sp>
+        <p:nvSpPr>
+          <p:cNvPr id="20" name="">
+            <a:extLst xmlns:a="http://schemas.openxmlformats.org/drawingml/2006/main">
+              <a:ext uri="{FF2B5EF4-FFF2-40B4-BE49-F238E27FC236}">
+                <a16:creationId xmlns:a16="http://schemas.microsoft.com/office/drawing/2014/main" id="{E63CF986-8C69-4502-A80A-D6FF79DAFE13}"/>
+              </a:ext>
+            </a:extLst>
+          </p:cNvPr>
+          <p:cNvSpPr>
+            <a:spLocks xmlns:a="http://schemas.openxmlformats.org/drawingml/2006/main" noGrp="1"/>
+          </p:cNvSpPr>
+          <p:nvPr/>
+        </p:nvSpPr>
+        <p:spPr>
+          <a:xfrm xmlns:a="http://schemas.openxmlformats.org/drawingml/2006/main">
+            <a:off x="6000750" y="2209800"/>
+            <a:ext cx="1609725" cy="628650"/>
+          </a:xfrm>
+          <a:prstGeom xmlns:a="http://schemas.openxmlformats.org/drawingml/2006/main" prst="rect">
+            <a:avLst/>
+          </a:prstGeom>
+          <a:solidFill xmlns:a="http://schemas.openxmlformats.org/drawingml/2006/main">
+            <a:srgbClr val="000000">
+              <a:alpha val="0"/>
+            </a:srgbClr>
+          </a:solidFill>
+          <a:ln xmlns:a="http://schemas.openxmlformats.org/drawingml/2006/main" w="0">
+            <a:solidFill>
+              <a:srgbClr val="000000">
+                <a:alpha val="0"/>
+              </a:srgbClr>
+            </a:solidFill>
+            <a:prstDash val="solid"/>
+          </a:ln>
+        </p:spPr>
+        <p:txBody>
+          <a:bodyPr xmlns:a="http://schemas.openxmlformats.org/drawingml/2006/main" lIns="0" tIns="0" rIns="0" bIns="0" anchor="t"/>
+          <a:lstStyle xmlns:a="http://schemas.openxmlformats.org/drawingml/2006/main"/>
+          <a:p xmlns:a="http://schemas.openxmlformats.org/drawingml/2006/main">
+            <a:pPr algn="l">
+              <a:defRPr sz="825" b="0">
+                <a:solidFill>
+                  <a:srgbClr val="526172"/>
+                </a:solidFill>
+                <a:latin typeface="Aptos"/>
+                <a:ea typeface="Aptos"/>
+                <a:cs typeface="Aptos"/>
+              </a:defRPr>
+            </a:pPr>
+            <a:r>
+              <a:rPr sz="825" b="0">
+                <a:solidFill>
+                  <a:srgbClr val="526172"/>
+                </a:solidFill>
+                <a:latin typeface="Aptos"/>
+                <a:ea typeface="Aptos"/>
+                <a:cs typeface="Aptos"/>
+              </a:rPr>
+              <a:t>Correlation key joins same-kind alerts by rule, host, user, source, MITRE, and time window.</a:t>
+            </a:r>
+          </a:p>
+        </p:txBody>
+      </p:sp>
+      <p:sp>
+        <p:nvSpPr>
+          <p:cNvPr id="21" name="">
+            <a:extLst xmlns:a="http://schemas.openxmlformats.org/drawingml/2006/main">
+              <a:ext uri="{FF2B5EF4-FFF2-40B4-BE49-F238E27FC236}">
+                <a16:creationId xmlns:a16="http://schemas.microsoft.com/office/drawing/2014/main" id="{9B02EAB9-F4F6-4F3A-BDEB-D34136F0819F}"/>
+              </a:ext>
+            </a:extLst>
+          </p:cNvPr>
+          <p:cNvSpPr>
+            <a:spLocks xmlns:a="http://schemas.openxmlformats.org/drawingml/2006/main" noGrp="1"/>
+          </p:cNvSpPr>
+          <p:nvPr/>
+        </p:nvSpPr>
+        <p:spPr>
+          <a:xfrm xmlns:a="http://schemas.openxmlformats.org/drawingml/2006/main">
+            <a:off x="7858125" y="2266950"/>
+            <a:ext cx="552450" cy="66675"/>
+          </a:xfrm>
+          <a:prstGeom xmlns:a="http://schemas.openxmlformats.org/drawingml/2006/main" prst="rect">
+            <a:avLst/>
+          </a:prstGeom>
+          <a:solidFill xmlns:a="http://schemas.openxmlformats.org/drawingml/2006/main">
+            <a:srgbClr val="B8C4D6"/>
+          </a:solidFill>
+          <a:ln xmlns:a="http://schemas.openxmlformats.org/drawingml/2006/main" w="0">
+            <a:solidFill>
+              <a:srgbClr val="B8C4D6"/>
+            </a:solidFill>
+            <a:prstDash val="solid"/>
+          </a:ln>
+        </p:spPr>
+      </p:sp>
+      <p:sp>
+        <p:nvSpPr>
+          <p:cNvPr id="22" name="">
+            <a:extLst xmlns:a="http://schemas.openxmlformats.org/drawingml/2006/main">
+              <a:ext uri="{FF2B5EF4-FFF2-40B4-BE49-F238E27FC236}">
+                <a16:creationId xmlns:a16="http://schemas.microsoft.com/office/drawing/2014/main" id="{18673303-BD8F-4288-97AA-DDCD659C7A2D}"/>
+              </a:ext>
+            </a:extLst>
+          </p:cNvPr>
+          <p:cNvSpPr>
+            <a:spLocks xmlns:a="http://schemas.openxmlformats.org/drawingml/2006/main" noGrp="1"/>
+          </p:cNvSpPr>
+          <p:nvPr/>
+        </p:nvSpPr>
+        <p:spPr>
+          <a:xfrm xmlns:a="http://schemas.openxmlformats.org/drawingml/2006/main">
+            <a:off x="8391525" y="2190750"/>
+            <a:ext cx="171450" cy="209550"/>
+          </a:xfrm>
+          <a:prstGeom xmlns:a="http://schemas.openxmlformats.org/drawingml/2006/main" prst="triangle">
+            <a:avLst/>
+          </a:prstGeom>
+          <a:solidFill xmlns:a="http://schemas.openxmlformats.org/drawingml/2006/main">
+            <a:srgbClr val="B8C4D6"/>
+          </a:solidFill>
+          <a:ln xmlns:a="http://schemas.openxmlformats.org/drawingml/2006/main" w="0">
+            <a:solidFill>
+              <a:srgbClr val="B8C4D6"/>
+            </a:solidFill>
+            <a:prstDash val="solid"/>
+          </a:ln>
+        </p:spPr>
+      </p:sp>
+      <p:sp>
+        <p:nvSpPr>
+          <p:cNvPr id="23" name="">
+            <a:extLst xmlns:a="http://schemas.openxmlformats.org/drawingml/2006/main">
+              <a:ext uri="{FF2B5EF4-FFF2-40B4-BE49-F238E27FC236}">
+                <a16:creationId xmlns:a16="http://schemas.microsoft.com/office/drawing/2014/main" id="{7C8BF74D-6FD7-40CA-ADE8-2A2C9A170D71}"/>
+              </a:ext>
+            </a:extLst>
+          </p:cNvPr>
+          <p:cNvSpPr>
+            <a:spLocks xmlns:a="http://schemas.openxmlformats.org/drawingml/2006/main" noGrp="1"/>
+          </p:cNvSpPr>
+          <p:nvPr/>
+        </p:nvSpPr>
+        <p:spPr>
+          <a:xfrm xmlns:a="http://schemas.openxmlformats.org/drawingml/2006/main">
+            <a:off x="8477250" y="1695450"/>
+            <a:ext cx="2476500" cy="1257300"/>
+          </a:xfrm>
+          <a:prstGeom xmlns:a="http://schemas.openxmlformats.org/drawingml/2006/main" prst="rect">
+            <a:avLst/>
+          </a:prstGeom>
+          <a:solidFill xmlns:a="http://schemas.openxmlformats.org/drawingml/2006/main">
+            <a:srgbClr val="FFFFFF"/>
+          </a:solidFill>
+          <a:ln xmlns:a="http://schemas.openxmlformats.org/drawingml/2006/main" w="9525">
+            <a:solidFill>
+              <a:srgbClr val="D7DFEA"/>
+            </a:solidFill>
+            <a:prstDash val="solid"/>
+          </a:ln>
+        </p:spPr>
+      </p:sp>
+      <p:sp>
+        <p:nvSpPr>
+          <p:cNvPr id="24" name="">
+            <a:extLst xmlns:a="http://schemas.openxmlformats.org/drawingml/2006/main">
+              <a:ext uri="{FF2B5EF4-FFF2-40B4-BE49-F238E27FC236}">
+                <a16:creationId xmlns:a16="http://schemas.microsoft.com/office/drawing/2014/main" id="{95789615-F5F1-41F5-A92C-6F8A5D4EC6A7}"/>
+              </a:ext>
+            </a:extLst>
+          </p:cNvPr>
+          <p:cNvSpPr>
+            <a:spLocks xmlns:a="http://schemas.openxmlformats.org/drawingml/2006/main" noGrp="1"/>
+          </p:cNvSpPr>
+          <p:nvPr/>
+        </p:nvSpPr>
+        <p:spPr>
+          <a:xfrm xmlns:a="http://schemas.openxmlformats.org/drawingml/2006/main">
+            <a:off x="8477250" y="1695450"/>
+            <a:ext cx="2476500" cy="66675"/>
+          </a:xfrm>
+          <a:prstGeom xmlns:a="http://schemas.openxmlformats.org/drawingml/2006/main" prst="rect">
+            <a:avLst/>
+          </a:prstGeom>
+          <a:solidFill xmlns:a="http://schemas.openxmlformats.org/drawingml/2006/main">
+            <a:srgbClr val="6B5DD3"/>
+          </a:solidFill>
+          <a:ln xmlns:a="http://schemas.openxmlformats.org/drawingml/2006/main" w="0">
+            <a:solidFill>
+              <a:srgbClr val="6B5DD3"/>
+            </a:solidFill>
+            <a:prstDash val="solid"/>
+          </a:ln>
+        </p:spPr>
+      </p:sp>
+      <p:sp>
+        <p:nvSpPr>
+          <p:cNvPr id="25" name="">
+            <a:extLst xmlns:a="http://schemas.openxmlformats.org/drawingml/2006/main">
+              <a:ext uri="{FF2B5EF4-FFF2-40B4-BE49-F238E27FC236}">
+                <a16:creationId xmlns:a16="http://schemas.microsoft.com/office/drawing/2014/main" id="{1CD732F6-5470-42AC-970D-8158C53E5E3C}"/>
+              </a:ext>
+            </a:extLst>
+          </p:cNvPr>
+          <p:cNvSpPr>
+            <a:spLocks xmlns:a="http://schemas.openxmlformats.org/drawingml/2006/main" noGrp="1"/>
+          </p:cNvSpPr>
+          <p:nvPr/>
+        </p:nvSpPr>
+        <p:spPr>
+          <a:xfrm xmlns:a="http://schemas.openxmlformats.org/drawingml/2006/main">
+            <a:off x="8648700" y="1885950"/>
+            <a:ext cx="2133600" cy="228600"/>
+          </a:xfrm>
+          <a:prstGeom xmlns:a="http://schemas.openxmlformats.org/drawingml/2006/main" prst="rect">
+            <a:avLst/>
+          </a:prstGeom>
+          <a:solidFill xmlns:a="http://schemas.openxmlformats.org/drawingml/2006/main">
+            <a:srgbClr val="000000">
+              <a:alpha val="0"/>
+            </a:srgbClr>
+          </a:solidFill>
+          <a:ln xmlns:a="http://schemas.openxmlformats.org/drawingml/2006/main" w="0">
+            <a:solidFill>
+              <a:srgbClr val="000000">
+                <a:alpha val="0"/>
+              </a:srgbClr>
+            </a:solidFill>
+            <a:prstDash val="solid"/>
+          </a:ln>
+        </p:spPr>
+        <p:txBody>
+          <a:bodyPr xmlns:a="http://schemas.openxmlformats.org/drawingml/2006/main" lIns="0" tIns="0" rIns="0" bIns="0" anchor="t"/>
+          <a:lstStyle xmlns:a="http://schemas.openxmlformats.org/drawingml/2006/main"/>
+          <a:p xmlns:a="http://schemas.openxmlformats.org/drawingml/2006/main">
+            <a:pPr algn="l">
+              <a:defRPr sz="1050" b="1">
+                <a:solidFill>
+                  <a:srgbClr val="111827"/>
+                </a:solidFill>
+                <a:latin typeface="Aptos"/>
+                <a:ea typeface="Aptos"/>
+                <a:cs typeface="Aptos"/>
+              </a:defRPr>
+            </a:pPr>
+            <a:r>
+              <a:rPr sz="1050" b="1">
+                <a:solidFill>
+                  <a:srgbClr val="111827"/>
+                </a:solidFill>
+                <a:latin typeface="Aptos"/>
+                <a:ea typeface="Aptos"/>
+                <a:cs typeface="Aptos"/>
+              </a:rPr>
+              <a:t>4. AI Router</a:t>
+            </a:r>
+          </a:p>
+        </p:txBody>
+      </p:sp>
+      <p:sp>
+        <p:nvSpPr>
+          <p:cNvPr id="26" name="">
+            <a:extLst xmlns:a="http://schemas.openxmlformats.org/drawingml/2006/main">
+              <a:ext uri="{FF2B5EF4-FFF2-40B4-BE49-F238E27FC236}">
+                <a16:creationId xmlns:a16="http://schemas.microsoft.com/office/drawing/2014/main" id="{2C57B023-0FBE-4A82-98F9-D828523BC6FB}"/>
+              </a:ext>
+            </a:extLst>
+          </p:cNvPr>
+          <p:cNvSpPr>
+            <a:spLocks xmlns:a="http://schemas.openxmlformats.org/drawingml/2006/main" noGrp="1"/>
+          </p:cNvSpPr>
+          <p:nvPr/>
+        </p:nvSpPr>
+        <p:spPr>
+          <a:xfrm xmlns:a="http://schemas.openxmlformats.org/drawingml/2006/main">
+            <a:off x="8648700" y="2209800"/>
+            <a:ext cx="2133600" cy="628650"/>
+          </a:xfrm>
+          <a:prstGeom xmlns:a="http://schemas.openxmlformats.org/drawingml/2006/main" prst="rect">
+            <a:avLst/>
+          </a:prstGeom>
+          <a:solidFill xmlns:a="http://schemas.openxmlformats.org/drawingml/2006/main">
+            <a:srgbClr val="000000">
+              <a:alpha val="0"/>
+            </a:srgbClr>
+          </a:solidFill>
+          <a:ln xmlns:a="http://schemas.openxmlformats.org/drawingml/2006/main" w="0">
+            <a:solidFill>
+              <a:srgbClr val="000000">
+                <a:alpha val="0"/>
+              </a:srgbClr>
+            </a:solidFill>
+            <a:prstDash val="solid"/>
+          </a:ln>
+        </p:spPr>
+        <p:txBody>
+          <a:bodyPr xmlns:a="http://schemas.openxmlformats.org/drawingml/2006/main" lIns="0" tIns="0" rIns="0" bIns="0" anchor="t"/>
+          <a:lstStyle xmlns:a="http://schemas.openxmlformats.org/drawingml/2006/main"/>
+          <a:p xmlns:a="http://schemas.openxmlformats.org/drawingml/2006/main">
+            <a:pPr algn="l">
+              <a:defRPr sz="825" b="0">
+                <a:solidFill>
+                  <a:srgbClr val="526172"/>
+                </a:solidFill>
+                <a:latin typeface="Aptos"/>
+                <a:ea typeface="Aptos"/>
+                <a:cs typeface="Aptos"/>
+              </a:defRPr>
+            </a:pPr>
+            <a:r>
+              <a:rPr sz="825" b="0">
+                <a:solidFill>
+                  <a:srgbClr val="526172"/>
+                </a:solidFill>
+                <a:latin typeface="Aptos"/>
+                <a:ea typeface="Aptos"/>
+                <a:cs typeface="Aptos"/>
+              </a:rPr>
+              <a:t>Offline heuristic or Ollama for bulk triage; cloud mini model only for useful structured reasoning; stronger model only for high ambiguity.</a:t>
+            </a:r>
+          </a:p>
+        </p:txBody>
+      </p:sp>
+      <p:sp>
+        <p:nvSpPr>
+          <p:cNvPr id="27" name="">
+            <a:extLst xmlns:a="http://schemas.openxmlformats.org/drawingml/2006/main">
+              <a:ext uri="{FF2B5EF4-FFF2-40B4-BE49-F238E27FC236}">
+                <a16:creationId xmlns:a16="http://schemas.microsoft.com/office/drawing/2014/main" id="{FC322030-3385-404D-AE6A-517B90A8C09B}"/>
+              </a:ext>
+            </a:extLst>
+          </p:cNvPr>
+          <p:cNvSpPr>
+            <a:spLocks xmlns:a="http://schemas.openxmlformats.org/drawingml/2006/main" noGrp="1"/>
+          </p:cNvSpPr>
+          <p:nvPr/>
+        </p:nvSpPr>
+        <p:spPr>
+          <a:xfrm xmlns:a="http://schemas.openxmlformats.org/drawingml/2006/main">
+            <a:off x="1104900" y="3676650"/>
+            <a:ext cx="3752850" cy="1352550"/>
+          </a:xfrm>
+          <a:prstGeom xmlns:a="http://schemas.openxmlformats.org/drawingml/2006/main" prst="rect">
+            <a:avLst/>
+          </a:prstGeom>
+          <a:solidFill xmlns:a="http://schemas.openxmlformats.org/drawingml/2006/main">
+            <a:srgbClr val="FFFFFF"/>
+          </a:solidFill>
+          <a:ln xmlns:a="http://schemas.openxmlformats.org/drawingml/2006/main" w="9525">
+            <a:solidFill>
+              <a:srgbClr val="D7DFEA"/>
+            </a:solidFill>
+            <a:prstDash val="solid"/>
+          </a:ln>
+        </p:spPr>
+      </p:sp>
+      <p:sp>
+        <p:nvSpPr>
+          <p:cNvPr id="28" name="">
+            <a:extLst xmlns:a="http://schemas.openxmlformats.org/drawingml/2006/main">
+              <a:ext uri="{FF2B5EF4-FFF2-40B4-BE49-F238E27FC236}">
+                <a16:creationId xmlns:a16="http://schemas.microsoft.com/office/drawing/2014/main" id="{FD634DF6-6944-4A71-A525-059B685BA065}"/>
+              </a:ext>
+            </a:extLst>
+          </p:cNvPr>
+          <p:cNvSpPr>
+            <a:spLocks xmlns:a="http://schemas.openxmlformats.org/drawingml/2006/main" noGrp="1"/>
+          </p:cNvSpPr>
+          <p:nvPr/>
+        </p:nvSpPr>
+        <p:spPr>
+          <a:xfrm xmlns:a="http://schemas.openxmlformats.org/drawingml/2006/main">
+            <a:off x="1333500" y="3905250"/>
+            <a:ext cx="3238500" cy="228600"/>
+          </a:xfrm>
+          <a:prstGeom xmlns:a="http://schemas.openxmlformats.org/drawingml/2006/main" prst="rect">
+            <a:avLst/>
+          </a:prstGeom>
+          <a:solidFill xmlns:a="http://schemas.openxmlformats.org/drawingml/2006/main">
+            <a:srgbClr val="000000">
+              <a:alpha val="0"/>
+            </a:srgbClr>
+          </a:solidFill>
+          <a:ln xmlns:a="http://schemas.openxmlformats.org/drawingml/2006/main" w="0">
+            <a:solidFill>
+              <a:srgbClr val="000000">
+                <a:alpha val="0"/>
+              </a:srgbClr>
+            </a:solidFill>
+            <a:prstDash val="solid"/>
+          </a:ln>
+        </p:spPr>
+        <p:txBody>
+          <a:bodyPr xmlns:a="http://schemas.openxmlformats.org/drawingml/2006/main" lIns="0" tIns="0" rIns="0" bIns="0" anchor="t"/>
+          <a:lstStyle xmlns:a="http://schemas.openxmlformats.org/drawingml/2006/main"/>
+          <a:p xmlns:a="http://schemas.openxmlformats.org/drawingml/2006/main">
+            <a:pPr algn="l">
+              <a:defRPr sz="1275" b="1">
+                <a:solidFill>
+                  <a:srgbClr val="111827"/>
+                </a:solidFill>
+                <a:latin typeface="Aptos"/>
+                <a:ea typeface="Aptos"/>
+                <a:cs typeface="Aptos"/>
+              </a:defRPr>
+            </a:pPr>
+            <a:r>
+              <a:rPr sz="1275" b="1">
+                <a:solidFill>
+                  <a:srgbClr val="111827"/>
+                </a:solidFill>
+                <a:latin typeface="Aptos"/>
+                <a:ea typeface="Aptos"/>
+                <a:cs typeface="Aptos"/>
+              </a:rPr>
+              <a:t>Analyst Feedback Loop</a:t>
+            </a:r>
+          </a:p>
+        </p:txBody>
+      </p:sp>
+      <p:sp>
+        <p:nvSpPr>
+          <p:cNvPr id="29" name="">
+            <a:extLst xmlns:a="http://schemas.openxmlformats.org/drawingml/2006/main">
+              <a:ext uri="{FF2B5EF4-FFF2-40B4-BE49-F238E27FC236}">
+                <a16:creationId xmlns:a16="http://schemas.microsoft.com/office/drawing/2014/main" id="{F9A49C34-85BD-420A-BF90-84264B8676A9}"/>
+              </a:ext>
+            </a:extLst>
+          </p:cNvPr>
+          <p:cNvSpPr>
+            <a:spLocks xmlns:a="http://schemas.openxmlformats.org/drawingml/2006/main" noGrp="1"/>
+          </p:cNvSpPr>
+          <p:nvPr/>
+        </p:nvSpPr>
+        <p:spPr>
+          <a:xfrm xmlns:a="http://schemas.openxmlformats.org/drawingml/2006/main">
+            <a:off x="1371600" y="4343400"/>
+            <a:ext cx="95250" cy="95250"/>
+          </a:xfrm>
+          <a:prstGeom xmlns:a="http://schemas.openxmlformats.org/drawingml/2006/main" prst="rect">
+            <a:avLst/>
+          </a:prstGeom>
+          <a:solidFill xmlns:a="http://schemas.openxmlformats.org/drawingml/2006/main">
+            <a:srgbClr val="22A06B"/>
+          </a:solidFill>
+          <a:ln xmlns:a="http://schemas.openxmlformats.org/drawingml/2006/main" w="0">
+            <a:solidFill>
+              <a:srgbClr val="22A06B"/>
+            </a:solidFill>
+            <a:prstDash val="solid"/>
+          </a:ln>
+        </p:spPr>
+      </p:sp>
+      <p:sp>
+        <p:nvSpPr>
+          <p:cNvPr id="30" name="">
+            <a:extLst xmlns:a="http://schemas.openxmlformats.org/drawingml/2006/main">
+              <a:ext uri="{FF2B5EF4-FFF2-40B4-BE49-F238E27FC236}">
+                <a16:creationId xmlns:a16="http://schemas.microsoft.com/office/drawing/2014/main" id="{393C6401-2816-46A1-99A7-C675ABBAAA7E}"/>
+              </a:ext>
+            </a:extLst>
+          </p:cNvPr>
+          <p:cNvSpPr>
+            <a:spLocks xmlns:a="http://schemas.openxmlformats.org/drawingml/2006/main" noGrp="1"/>
+          </p:cNvSpPr>
+          <p:nvPr/>
+        </p:nvSpPr>
+        <p:spPr>
+          <a:xfrm xmlns:a="http://schemas.openxmlformats.org/drawingml/2006/main">
+            <a:off x="1562100" y="4305300"/>
+            <a:ext cx="4095750" cy="238125"/>
+          </a:xfrm>
+          <a:prstGeom xmlns:a="http://schemas.openxmlformats.org/drawingml/2006/main" prst="rect">
+            <a:avLst/>
+          </a:prstGeom>
+          <a:solidFill xmlns:a="http://schemas.openxmlformats.org/drawingml/2006/main">
+            <a:srgbClr val="000000">
+              <a:alpha val="0"/>
+            </a:srgbClr>
+          </a:solidFill>
+          <a:ln xmlns:a="http://schemas.openxmlformats.org/drawingml/2006/main" w="0">
+            <a:solidFill>
+              <a:srgbClr val="000000">
+                <a:alpha val="0"/>
+              </a:srgbClr>
+            </a:solidFill>
+            <a:prstDash val="solid"/>
+          </a:ln>
+        </p:spPr>
+        <p:txBody>
+          <a:bodyPr xmlns:a="http://schemas.openxmlformats.org/drawingml/2006/main" lIns="0" tIns="0" rIns="0" bIns="0" anchor="t"/>
+          <a:lstStyle xmlns:a="http://schemas.openxmlformats.org/drawingml/2006/main"/>
+          <a:p xmlns:a="http://schemas.openxmlformats.org/drawingml/2006/main">
+            <a:pPr algn="l">
+              <a:defRPr sz="975" b="0">
+                <a:solidFill>
+                  <a:srgbClr val="526172"/>
+                </a:solidFill>
+                <a:latin typeface="Aptos"/>
+                <a:ea typeface="Aptos"/>
+                <a:cs typeface="Aptos"/>
+              </a:defRPr>
+            </a:pPr>
+            <a:r>
+              <a:rPr sz="975" b="0">
+                <a:solidFill>
+                  <a:srgbClr val="526172"/>
+                </a:solidFill>
+                <a:latin typeface="Aptos"/>
+                <a:ea typeface="Aptos"/>
+                <a:cs typeface="Aptos"/>
+              </a:rPr>
+              <a:t>True positive / false positive / benign admin activity labels</a:t>
+            </a:r>
+          </a:p>
+        </p:txBody>
+      </p:sp>
+      <p:sp>
+        <p:nvSpPr>
+          <p:cNvPr id="31" name="">
+            <a:extLst xmlns:a="http://schemas.openxmlformats.org/drawingml/2006/main">
+              <a:ext uri="{FF2B5EF4-FFF2-40B4-BE49-F238E27FC236}">
+                <a16:creationId xmlns:a16="http://schemas.microsoft.com/office/drawing/2014/main" id="{425B49DF-FEC3-4DE1-9E9F-371DE8756068}"/>
+              </a:ext>
+            </a:extLst>
+          </p:cNvPr>
+          <p:cNvSpPr>
+            <a:spLocks xmlns:a="http://schemas.openxmlformats.org/drawingml/2006/main" noGrp="1"/>
+          </p:cNvSpPr>
+          <p:nvPr/>
+        </p:nvSpPr>
+        <p:spPr>
+          <a:xfrm xmlns:a="http://schemas.openxmlformats.org/drawingml/2006/main">
+            <a:off x="1371600" y="4667250"/>
+            <a:ext cx="95250" cy="95250"/>
+          </a:xfrm>
+          <a:prstGeom xmlns:a="http://schemas.openxmlformats.org/drawingml/2006/main" prst="rect">
+            <a:avLst/>
+          </a:prstGeom>
+          <a:solidFill xmlns:a="http://schemas.openxmlformats.org/drawingml/2006/main">
+            <a:srgbClr val="22A06B"/>
+          </a:solidFill>
+          <a:ln xmlns:a="http://schemas.openxmlformats.org/drawingml/2006/main" w="0">
+            <a:solidFill>
+              <a:srgbClr val="22A06B"/>
+            </a:solidFill>
+            <a:prstDash val="solid"/>
+          </a:ln>
+        </p:spPr>
+      </p:sp>
+      <p:sp>
+        <p:nvSpPr>
+          <p:cNvPr id="32" name="">
+            <a:extLst xmlns:a="http://schemas.openxmlformats.org/drawingml/2006/main">
+              <a:ext uri="{FF2B5EF4-FFF2-40B4-BE49-F238E27FC236}">
+                <a16:creationId xmlns:a16="http://schemas.microsoft.com/office/drawing/2014/main" id="{C86B5876-8603-4D00-85F7-65E9243EEE38}"/>
+              </a:ext>
+            </a:extLst>
+          </p:cNvPr>
+          <p:cNvSpPr>
+            <a:spLocks xmlns:a="http://schemas.openxmlformats.org/drawingml/2006/main" noGrp="1"/>
+          </p:cNvSpPr>
+          <p:nvPr/>
+        </p:nvSpPr>
+        <p:spPr>
+          <a:xfrm xmlns:a="http://schemas.openxmlformats.org/drawingml/2006/main">
+            <a:off x="1562100" y="4629150"/>
+            <a:ext cx="4095750" cy="238125"/>
+          </a:xfrm>
+          <a:prstGeom xmlns:a="http://schemas.openxmlformats.org/drawingml/2006/main" prst="rect">
+            <a:avLst/>
+          </a:prstGeom>
+          <a:solidFill xmlns:a="http://schemas.openxmlformats.org/drawingml/2006/main">
+            <a:srgbClr val="000000">
+              <a:alpha val="0"/>
+            </a:srgbClr>
+          </a:solidFill>
+          <a:ln xmlns:a="http://schemas.openxmlformats.org/drawingml/2006/main" w="0">
+            <a:solidFill>
+              <a:srgbClr val="000000">
+                <a:alpha val="0"/>
+              </a:srgbClr>
+            </a:solidFill>
+            <a:prstDash val="solid"/>
+          </a:ln>
+        </p:spPr>
+        <p:txBody>
+          <a:bodyPr xmlns:a="http://schemas.openxmlformats.org/drawingml/2006/main" lIns="0" tIns="0" rIns="0" bIns="0" anchor="t"/>
+          <a:lstStyle xmlns:a="http://schemas.openxmlformats.org/drawingml/2006/main"/>
+          <a:p xmlns:a="http://schemas.openxmlformats.org/drawingml/2006/main">
+            <a:pPr algn="l">
+              <a:defRPr sz="975" b="0">
+                <a:solidFill>
+                  <a:srgbClr val="526172"/>
+                </a:solidFill>
+                <a:latin typeface="Aptos"/>
+                <a:ea typeface="Aptos"/>
+                <a:cs typeface="Aptos"/>
+              </a:defRPr>
+            </a:pPr>
+            <a:r>
+              <a:rPr sz="975" b="0">
+                <a:solidFill>
+                  <a:srgbClr val="526172"/>
+                </a:solidFill>
+                <a:latin typeface="Aptos"/>
+                <a:ea typeface="Aptos"/>
+                <a:cs typeface="Aptos"/>
+              </a:rPr>
+              <a:t>Suppression approval, resolution reason, and case outcome</a:t>
+            </a:r>
+          </a:p>
+        </p:txBody>
+      </p:sp>
+      <p:sp>
+        <p:nvSpPr>
+          <p:cNvPr id="33" name="">
+            <a:extLst xmlns:a="http://schemas.openxmlformats.org/drawingml/2006/main">
+              <a:ext uri="{FF2B5EF4-FFF2-40B4-BE49-F238E27FC236}">
+                <a16:creationId xmlns:a16="http://schemas.microsoft.com/office/drawing/2014/main" id="{8BFF17B2-7803-49CC-B0C9-0AAF4EC6E006}"/>
+              </a:ext>
+            </a:extLst>
+          </p:cNvPr>
+          <p:cNvSpPr>
+            <a:spLocks xmlns:a="http://schemas.openxmlformats.org/drawingml/2006/main" noGrp="1"/>
+          </p:cNvSpPr>
+          <p:nvPr/>
+        </p:nvSpPr>
+        <p:spPr>
+          <a:xfrm xmlns:a="http://schemas.openxmlformats.org/drawingml/2006/main">
+            <a:off x="1371600" y="4991100"/>
+            <a:ext cx="95250" cy="95250"/>
+          </a:xfrm>
+          <a:prstGeom xmlns:a="http://schemas.openxmlformats.org/drawingml/2006/main" prst="rect">
+            <a:avLst/>
+          </a:prstGeom>
+          <a:solidFill xmlns:a="http://schemas.openxmlformats.org/drawingml/2006/main">
+            <a:srgbClr val="22A06B"/>
+          </a:solidFill>
+          <a:ln xmlns:a="http://schemas.openxmlformats.org/drawingml/2006/main" w="0">
+            <a:solidFill>
+              <a:srgbClr val="22A06B"/>
+            </a:solidFill>
+            <a:prstDash val="solid"/>
+          </a:ln>
+        </p:spPr>
+      </p:sp>
+      <p:sp>
+        <p:nvSpPr>
+          <p:cNvPr id="34" name="">
+            <a:extLst xmlns:a="http://schemas.openxmlformats.org/drawingml/2006/main">
+              <a:ext uri="{FF2B5EF4-FFF2-40B4-BE49-F238E27FC236}">
+                <a16:creationId xmlns:a16="http://schemas.microsoft.com/office/drawing/2014/main" id="{A608D7EA-6519-4271-B853-F884A90C464F}"/>
+              </a:ext>
+            </a:extLst>
+          </p:cNvPr>
+          <p:cNvSpPr>
+            <a:spLocks xmlns:a="http://schemas.openxmlformats.org/drawingml/2006/main" noGrp="1"/>
+          </p:cNvSpPr>
+          <p:nvPr/>
+        </p:nvSpPr>
+        <p:spPr>
+          <a:xfrm xmlns:a="http://schemas.openxmlformats.org/drawingml/2006/main">
+            <a:off x="1562100" y="4953000"/>
+            <a:ext cx="4095750" cy="238125"/>
+          </a:xfrm>
+          <a:prstGeom xmlns:a="http://schemas.openxmlformats.org/drawingml/2006/main" prst="rect">
+            <a:avLst/>
+          </a:prstGeom>
+          <a:solidFill xmlns:a="http://schemas.openxmlformats.org/drawingml/2006/main">
+            <a:srgbClr val="000000">
+              <a:alpha val="0"/>
+            </a:srgbClr>
+          </a:solidFill>
+          <a:ln xmlns:a="http://schemas.openxmlformats.org/drawingml/2006/main" w="0">
+            <a:solidFill>
+              <a:srgbClr val="000000">
+                <a:alpha val="0"/>
+              </a:srgbClr>
+            </a:solidFill>
+            <a:prstDash val="solid"/>
+          </a:ln>
+        </p:spPr>
+        <p:txBody>
+          <a:bodyPr xmlns:a="http://schemas.openxmlformats.org/drawingml/2006/main" lIns="0" tIns="0" rIns="0" bIns="0" anchor="t"/>
+          <a:lstStyle xmlns:a="http://schemas.openxmlformats.org/drawingml/2006/main"/>
+          <a:p xmlns:a="http://schemas.openxmlformats.org/drawingml/2006/main">
+            <a:pPr algn="l">
+              <a:defRPr sz="975" b="0">
+                <a:solidFill>
+                  <a:srgbClr val="526172"/>
+                </a:solidFill>
+                <a:latin typeface="Aptos"/>
+                <a:ea typeface="Aptos"/>
+                <a:cs typeface="Aptos"/>
+              </a:defRPr>
+            </a:pPr>
+            <a:r>
+              <a:rPr sz="975" b="0">
+                <a:solidFill>
+                  <a:srgbClr val="526172"/>
+                </a:solidFill>
+                <a:latin typeface="Aptos"/>
+                <a:ea typeface="Aptos"/>
+                <a:cs typeface="Aptos"/>
+              </a:rPr>
+              <a:t>Promotes repeatable decisions into tuning memory</a:t>
+            </a:r>
+          </a:p>
+        </p:txBody>
+      </p:sp>
+      <p:sp>
+        <p:nvSpPr>
+          <p:cNvPr id="35" name="">
+            <a:extLst xmlns:a="http://schemas.openxmlformats.org/drawingml/2006/main">
+              <a:ext uri="{FF2B5EF4-FFF2-40B4-BE49-F238E27FC236}">
+                <a16:creationId xmlns:a16="http://schemas.microsoft.com/office/drawing/2014/main" id="{076B80FD-A81E-4626-BB52-479F1F282C0C}"/>
+              </a:ext>
+            </a:extLst>
+          </p:cNvPr>
+          <p:cNvSpPr>
+            <a:spLocks xmlns:a="http://schemas.openxmlformats.org/drawingml/2006/main" noGrp="1"/>
+          </p:cNvSpPr>
+          <p:nvPr/>
+        </p:nvSpPr>
+        <p:spPr>
+          <a:xfrm xmlns:a="http://schemas.openxmlformats.org/drawingml/2006/main">
+            <a:off x="5286375" y="3676650"/>
+            <a:ext cx="2762250" cy="1352550"/>
+          </a:xfrm>
+          <a:prstGeom xmlns:a="http://schemas.openxmlformats.org/drawingml/2006/main" prst="rect">
+            <a:avLst/>
+          </a:prstGeom>
+          <a:solidFill xmlns:a="http://schemas.openxmlformats.org/drawingml/2006/main">
+            <a:srgbClr val="FFF3D6"/>
+          </a:solidFill>
+          <a:ln xmlns:a="http://schemas.openxmlformats.org/drawingml/2006/main" w="9525">
+            <a:solidFill>
+              <a:srgbClr val="F3D38A"/>
+            </a:solidFill>
+            <a:prstDash val="solid"/>
+          </a:ln>
+        </p:spPr>
+      </p:sp>
+      <p:sp>
+        <p:nvSpPr>
+          <p:cNvPr id="36" name="">
+            <a:extLst xmlns:a="http://schemas.openxmlformats.org/drawingml/2006/main">
+              <a:ext uri="{FF2B5EF4-FFF2-40B4-BE49-F238E27FC236}">
+                <a16:creationId xmlns:a16="http://schemas.microsoft.com/office/drawing/2014/main" id="{3D9E8C23-6854-432B-8861-F27108E14AD1}"/>
+              </a:ext>
+            </a:extLst>
+          </p:cNvPr>
+          <p:cNvSpPr>
+            <a:spLocks xmlns:a="http://schemas.openxmlformats.org/drawingml/2006/main" noGrp="1"/>
+          </p:cNvSpPr>
+          <p:nvPr/>
+        </p:nvSpPr>
+        <p:spPr>
+          <a:xfrm xmlns:a="http://schemas.openxmlformats.org/drawingml/2006/main">
+            <a:off x="5524500" y="3905250"/>
+            <a:ext cx="2286000" cy="228600"/>
+          </a:xfrm>
+          <a:prstGeom xmlns:a="http://schemas.openxmlformats.org/drawingml/2006/main" prst="rect">
+            <a:avLst/>
+          </a:prstGeom>
+          <a:solidFill xmlns:a="http://schemas.openxmlformats.org/drawingml/2006/main">
+            <a:srgbClr val="000000">
+              <a:alpha val="0"/>
+            </a:srgbClr>
+          </a:solidFill>
+          <a:ln xmlns:a="http://schemas.openxmlformats.org/drawingml/2006/main" w="0">
+            <a:solidFill>
+              <a:srgbClr val="000000">
+                <a:alpha val="0"/>
+              </a:srgbClr>
+            </a:solidFill>
+            <a:prstDash val="solid"/>
+          </a:ln>
+        </p:spPr>
+        <p:txBody>
+          <a:bodyPr xmlns:a="http://schemas.openxmlformats.org/drawingml/2006/main" lIns="0" tIns="0" rIns="0" bIns="0" anchor="t"/>
+          <a:lstStyle xmlns:a="http://schemas.openxmlformats.org/drawingml/2006/main"/>
+          <a:p xmlns:a="http://schemas.openxmlformats.org/drawingml/2006/main">
+            <a:pPr algn="l">
+              <a:defRPr sz="1275" b="1">
+                <a:solidFill>
+                  <a:srgbClr val="111827"/>
+                </a:solidFill>
+                <a:latin typeface="Aptos"/>
+                <a:ea typeface="Aptos"/>
+                <a:cs typeface="Aptos"/>
+              </a:defRPr>
+            </a:pPr>
+            <a:r>
+              <a:rPr sz="1275" b="1">
+                <a:solidFill>
+                  <a:srgbClr val="111827"/>
+                </a:solidFill>
+                <a:latin typeface="Aptos"/>
+                <a:ea typeface="Aptos"/>
+                <a:cs typeface="Aptos"/>
+              </a:rPr>
+              <a:t>Long-Term Reliability</a:t>
+            </a:r>
+          </a:p>
+        </p:txBody>
+      </p:sp>
+      <p:sp>
+        <p:nvSpPr>
+          <p:cNvPr id="37" name="">
+            <a:extLst xmlns:a="http://schemas.openxmlformats.org/drawingml/2006/main">
+              <a:ext uri="{FF2B5EF4-FFF2-40B4-BE49-F238E27FC236}">
+                <a16:creationId xmlns:a16="http://schemas.microsoft.com/office/drawing/2014/main" id="{C0932BF0-B094-4FEC-ABD3-2F04EE28B446}"/>
+              </a:ext>
+            </a:extLst>
+          </p:cNvPr>
+          <p:cNvSpPr>
+            <a:spLocks xmlns:a="http://schemas.openxmlformats.org/drawingml/2006/main" noGrp="1"/>
+          </p:cNvSpPr>
+          <p:nvPr/>
+        </p:nvSpPr>
+        <p:spPr>
+          <a:xfrm xmlns:a="http://schemas.openxmlformats.org/drawingml/2006/main">
+            <a:off x="5524500" y="4305300"/>
+            <a:ext cx="2266950" cy="571500"/>
+          </a:xfrm>
+          <a:prstGeom xmlns:a="http://schemas.openxmlformats.org/drawingml/2006/main" prst="rect">
+            <a:avLst/>
+          </a:prstGeom>
+          <a:solidFill xmlns:a="http://schemas.openxmlformats.org/drawingml/2006/main">
+            <a:srgbClr val="000000">
+              <a:alpha val="0"/>
+            </a:srgbClr>
+          </a:solidFill>
+          <a:ln xmlns:a="http://schemas.openxmlformats.org/drawingml/2006/main" w="0">
+            <a:solidFill>
+              <a:srgbClr val="000000">
+                <a:alpha val="0"/>
+              </a:srgbClr>
+            </a:solidFill>
+            <a:prstDash val="solid"/>
+          </a:ln>
+        </p:spPr>
+        <p:txBody>
+          <a:bodyPr xmlns:a="http://schemas.openxmlformats.org/drawingml/2006/main" lIns="0" tIns="0" rIns="0" bIns="0" anchor="t"/>
+          <a:lstStyle xmlns:a="http://schemas.openxmlformats.org/drawingml/2006/main"/>
+          <a:p xmlns:a="http://schemas.openxmlformats.org/drawingml/2006/main">
+            <a:pPr algn="l">
+              <a:defRPr sz="975" b="1">
+                <a:solidFill>
+                  <a:srgbClr val="526172"/>
+                </a:solidFill>
+                <a:latin typeface="Aptos"/>
+                <a:ea typeface="Aptos"/>
+                <a:cs typeface="Aptos"/>
+              </a:defRPr>
+            </a:pPr>
+            <a:r>
+              <a:rPr sz="975" b="1">
+                <a:solidFill>
+                  <a:srgbClr val="526172"/>
+                </a:solidFill>
+                <a:latin typeface="Aptos"/>
+                <a:ea typeface="Aptos"/>
+                <a:cs typeface="Aptos"/>
+              </a:rPr>
+              <a:t>More alerts produce better baselines: duplicate grouping improves, token calls fall, suppression gets safer, and L2 receives richer evidence.</a:t>
+            </a:r>
+          </a:p>
+        </p:txBody>
+      </p:sp>
+      <p:sp>
+        <p:nvSpPr>
+          <p:cNvPr id="38" name="">
+            <a:extLst xmlns:a="http://schemas.openxmlformats.org/drawingml/2006/main">
+              <a:ext uri="{FF2B5EF4-FFF2-40B4-BE49-F238E27FC236}">
+                <a16:creationId xmlns:a16="http://schemas.microsoft.com/office/drawing/2014/main" id="{562E8EEA-A880-45F2-9892-036E6349C1CE}"/>
+              </a:ext>
+            </a:extLst>
+          </p:cNvPr>
+          <p:cNvSpPr>
+            <a:spLocks xmlns:a="http://schemas.openxmlformats.org/drawingml/2006/main" noGrp="1"/>
+          </p:cNvSpPr>
+          <p:nvPr/>
+        </p:nvSpPr>
+        <p:spPr>
+          <a:xfrm xmlns:a="http://schemas.openxmlformats.org/drawingml/2006/main">
+            <a:off x="8477250" y="3676650"/>
+            <a:ext cx="2476500" cy="1352550"/>
+          </a:xfrm>
+          <a:prstGeom xmlns:a="http://schemas.openxmlformats.org/drawingml/2006/main" prst="rect">
+            <a:avLst/>
+          </a:prstGeom>
+          <a:solidFill xmlns:a="http://schemas.openxmlformats.org/drawingml/2006/main">
+            <a:srgbClr val="E5F7EF"/>
+          </a:solidFill>
+          <a:ln xmlns:a="http://schemas.openxmlformats.org/drawingml/2006/main" w="9525">
+            <a:solidFill>
+              <a:srgbClr val="BDEDD7"/>
+            </a:solidFill>
+            <a:prstDash val="solid"/>
+          </a:ln>
+        </p:spPr>
+      </p:sp>
+      <p:sp>
+        <p:nvSpPr>
+          <p:cNvPr id="39" name="">
+            <a:extLst xmlns:a="http://schemas.openxmlformats.org/drawingml/2006/main">
+              <a:ext uri="{FF2B5EF4-FFF2-40B4-BE49-F238E27FC236}">
+                <a16:creationId xmlns:a16="http://schemas.microsoft.com/office/drawing/2014/main" id="{FBE38D9F-A17B-4246-9A31-8BBFADD3B1A4}"/>
+              </a:ext>
+            </a:extLst>
+          </p:cNvPr>
+          <p:cNvSpPr>
+            <a:spLocks xmlns:a="http://schemas.openxmlformats.org/drawingml/2006/main" noGrp="1"/>
+          </p:cNvSpPr>
+          <p:nvPr/>
+        </p:nvSpPr>
+        <p:spPr>
+          <a:xfrm xmlns:a="http://schemas.openxmlformats.org/drawingml/2006/main">
+            <a:off x="8705850" y="3905250"/>
+            <a:ext cx="2095500" cy="228600"/>
+          </a:xfrm>
+          <a:prstGeom xmlns:a="http://schemas.openxmlformats.org/drawingml/2006/main" prst="rect">
+            <a:avLst/>
+          </a:prstGeom>
+          <a:solidFill xmlns:a="http://schemas.openxmlformats.org/drawingml/2006/main">
+            <a:srgbClr val="000000">
+              <a:alpha val="0"/>
+            </a:srgbClr>
+          </a:solidFill>
+          <a:ln xmlns:a="http://schemas.openxmlformats.org/drawingml/2006/main" w="0">
+            <a:solidFill>
+              <a:srgbClr val="000000">
+                <a:alpha val="0"/>
+              </a:srgbClr>
+            </a:solidFill>
+            <a:prstDash val="solid"/>
+          </a:ln>
+        </p:spPr>
+        <p:txBody>
+          <a:bodyPr xmlns:a="http://schemas.openxmlformats.org/drawingml/2006/main" lIns="0" tIns="0" rIns="0" bIns="0" anchor="t"/>
+          <a:lstStyle xmlns:a="http://schemas.openxmlformats.org/drawingml/2006/main"/>
+          <a:p xmlns:a="http://schemas.openxmlformats.org/drawingml/2006/main">
+            <a:pPr algn="l">
+              <a:defRPr sz="1275" b="1">
+                <a:solidFill>
+                  <a:srgbClr val="111827"/>
+                </a:solidFill>
+                <a:latin typeface="Aptos"/>
+                <a:ea typeface="Aptos"/>
+                <a:cs typeface="Aptos"/>
+              </a:defRPr>
+            </a:pPr>
+            <a:r>
+              <a:rPr sz="1275" b="1">
+                <a:solidFill>
+                  <a:srgbClr val="111827"/>
+                </a:solidFill>
+                <a:latin typeface="Aptos"/>
+                <a:ea typeface="Aptos"/>
+                <a:cs typeface="Aptos"/>
+              </a:rPr>
+              <a:t>Future Upgrade Path</a:t>
+            </a:r>
+          </a:p>
+        </p:txBody>
+      </p:sp>
+      <p:sp>
+        <p:nvSpPr>
+          <p:cNvPr id="40" name="">
+            <a:extLst xmlns:a="http://schemas.openxmlformats.org/drawingml/2006/main">
+              <a:ext uri="{FF2B5EF4-FFF2-40B4-BE49-F238E27FC236}">
+                <a16:creationId xmlns:a16="http://schemas.microsoft.com/office/drawing/2014/main" id="{89240761-A58E-43B5-9909-923F6D23A8FB}"/>
+              </a:ext>
+            </a:extLst>
+          </p:cNvPr>
+          <p:cNvSpPr>
+            <a:spLocks xmlns:a="http://schemas.openxmlformats.org/drawingml/2006/main" noGrp="1"/>
+          </p:cNvSpPr>
+          <p:nvPr/>
+        </p:nvSpPr>
+        <p:spPr>
+          <a:xfrm xmlns:a="http://schemas.openxmlformats.org/drawingml/2006/main">
+            <a:off x="8705850" y="4305300"/>
+            <a:ext cx="2000250" cy="571500"/>
+          </a:xfrm>
+          <a:prstGeom xmlns:a="http://schemas.openxmlformats.org/drawingml/2006/main" prst="rect">
+            <a:avLst/>
+          </a:prstGeom>
+          <a:solidFill xmlns:a="http://schemas.openxmlformats.org/drawingml/2006/main">
+            <a:srgbClr val="000000">
+              <a:alpha val="0"/>
+            </a:srgbClr>
+          </a:solidFill>
+          <a:ln xmlns:a="http://schemas.openxmlformats.org/drawingml/2006/main" w="0">
+            <a:solidFill>
+              <a:srgbClr val="000000">
+                <a:alpha val="0"/>
+              </a:srgbClr>
+            </a:solidFill>
+            <a:prstDash val="solid"/>
+          </a:ln>
+        </p:spPr>
+        <p:txBody>
+          <a:bodyPr xmlns:a="http://schemas.openxmlformats.org/drawingml/2006/main" lIns="0" tIns="0" rIns="0" bIns="0" anchor="t"/>
+          <a:lstStyle xmlns:a="http://schemas.openxmlformats.org/drawingml/2006/main"/>
+          <a:p xmlns:a="http://schemas.openxmlformats.org/drawingml/2006/main">
+            <a:pPr algn="l">
+              <a:defRPr sz="975" b="1">
+                <a:solidFill>
+                  <a:srgbClr val="526172"/>
+                </a:solidFill>
+                <a:latin typeface="Aptos"/>
+                <a:ea typeface="Aptos"/>
+                <a:cs typeface="Aptos"/>
+              </a:defRPr>
+            </a:pPr>
+            <a:r>
+              <a:rPr sz="975" b="1">
+                <a:solidFill>
+                  <a:srgbClr val="526172"/>
+                </a:solidFill>
+                <a:latin typeface="Aptos"/>
+                <a:ea typeface="Aptos"/>
+                <a:cs typeface="Aptos"/>
+              </a:rPr>
+              <a:t>After enough validated labels, train customer-specific classifiers or prompt exemplars without sending raw sensitive logs outside.</a:t>
+            </a:r>
+          </a:p>
+        </p:txBody>
+      </p:sp>
+      <p:sp>
+        <p:nvSpPr>
+          <p:cNvPr id="41" name="">
+            <a:extLst xmlns:a="http://schemas.openxmlformats.org/drawingml/2006/main">
+              <a:ext uri="{FF2B5EF4-FFF2-40B4-BE49-F238E27FC236}">
+                <a16:creationId xmlns:a16="http://schemas.microsoft.com/office/drawing/2014/main" id="{C0F1C852-BABA-419A-8C8B-14FF32F43BCF}"/>
+              </a:ext>
+            </a:extLst>
+          </p:cNvPr>
+          <p:cNvSpPr>
+            <a:spLocks xmlns:a="http://schemas.openxmlformats.org/drawingml/2006/main" noGrp="1"/>
+          </p:cNvSpPr>
+          <p:nvPr/>
+        </p:nvSpPr>
+        <p:spPr>
+          <a:xfrm xmlns:a="http://schemas.openxmlformats.org/drawingml/2006/main">
+            <a:off x="1666875" y="5429250"/>
+            <a:ext cx="8191500" cy="495300"/>
+          </a:xfrm>
+          <a:prstGeom xmlns:a="http://schemas.openxmlformats.org/drawingml/2006/main" prst="rect">
+            <a:avLst/>
+          </a:prstGeom>
+          <a:solidFill xmlns:a="http://schemas.openxmlformats.org/drawingml/2006/main">
+            <a:srgbClr val="0B172A"/>
+          </a:solidFill>
+          <a:ln xmlns:a="http://schemas.openxmlformats.org/drawingml/2006/main" w="0">
+            <a:solidFill>
+              <a:srgbClr val="0B172A"/>
+            </a:solidFill>
+            <a:prstDash val="solid"/>
+          </a:ln>
+        </p:spPr>
+      </p:sp>
+      <p:sp>
+        <p:nvSpPr>
+          <p:cNvPr id="42" name="">
+            <a:extLst xmlns:a="http://schemas.openxmlformats.org/drawingml/2006/main">
+              <a:ext uri="{FF2B5EF4-FFF2-40B4-BE49-F238E27FC236}">
+                <a16:creationId xmlns:a16="http://schemas.microsoft.com/office/drawing/2014/main" id="{0A13AD78-D845-4C39-AAD6-2B6B577B2ECF}"/>
+              </a:ext>
+            </a:extLst>
+          </p:cNvPr>
+          <p:cNvSpPr>
+            <a:spLocks xmlns:a="http://schemas.openxmlformats.org/drawingml/2006/main" noGrp="1"/>
+          </p:cNvSpPr>
+          <p:nvPr/>
+        </p:nvSpPr>
+        <p:spPr>
+          <a:xfrm xmlns:a="http://schemas.openxmlformats.org/drawingml/2006/main">
+            <a:off x="2000250" y="5600700"/>
+            <a:ext cx="7524750" cy="171450"/>
+          </a:xfrm>
+          <a:prstGeom xmlns:a="http://schemas.openxmlformats.org/drawingml/2006/main" prst="rect">
+            <a:avLst/>
+          </a:prstGeom>
+          <a:solidFill xmlns:a="http://schemas.openxmlformats.org/drawingml/2006/main">
+            <a:srgbClr val="000000">
+              <a:alpha val="0"/>
+            </a:srgbClr>
+          </a:solidFill>
+          <a:ln xmlns:a="http://schemas.openxmlformats.org/drawingml/2006/main" w="0">
+            <a:solidFill>
+              <a:srgbClr val="000000">
+                <a:alpha val="0"/>
+              </a:srgbClr>
+            </a:solidFill>
+            <a:prstDash val="solid"/>
+          </a:ln>
+        </p:spPr>
+        <p:txBody>
+          <a:bodyPr xmlns:a="http://schemas.openxmlformats.org/drawingml/2006/main" lIns="0" tIns="0" rIns="0" bIns="0" anchor="t"/>
+          <a:lstStyle xmlns:a="http://schemas.openxmlformats.org/drawingml/2006/main"/>
+          <a:p xmlns:a="http://schemas.openxmlformats.org/drawingml/2006/main">
+            <a:pPr algn="ctr">
+              <a:defRPr sz="1200" b="1">
+                <a:solidFill>
+                  <a:srgbClr val="FFFFFF"/>
+                </a:solidFill>
+                <a:latin typeface="Aptos"/>
+                <a:ea typeface="Aptos"/>
+                <a:cs typeface="Aptos"/>
+              </a:defRPr>
+            </a:pPr>
+            <a:r>
+              <a:rPr sz="1200" b="1">
+                <a:solidFill>
+                  <a:srgbClr val="FFFFFF"/>
+                </a:solidFill>
+                <a:latin typeface="Aptos"/>
+                <a:ea typeface="Aptos"/>
+                <a:cs typeface="Aptos"/>
+              </a:rPr>
+              <a:t>Core brain outcome: fewer repeated alerts, more reliable AI triage, explainable grouping, and lower long-term token cost.</a:t>
+            </a:r>
+          </a:p>
+        </p:txBody>
+      </p:sp>
+      <p:sp>
+        <p:nvSpPr>
+          <p:cNvPr id="43" name="">
+            <a:extLst xmlns:a="http://schemas.openxmlformats.org/drawingml/2006/main">
+              <a:ext uri="{FF2B5EF4-FFF2-40B4-BE49-F238E27FC236}">
+                <a16:creationId xmlns:a16="http://schemas.microsoft.com/office/drawing/2014/main" id="{647DE201-DBB3-47CF-81A4-A8AF87CDE3DD}"/>
+              </a:ext>
+            </a:extLst>
+          </p:cNvPr>
+          <p:cNvSpPr>
+            <a:spLocks xmlns:a="http://schemas.openxmlformats.org/drawingml/2006/main" noGrp="1"/>
+          </p:cNvSpPr>
+          <p:nvPr/>
+        </p:nvSpPr>
+        <p:spPr>
+          <a:xfrm xmlns:a="http://schemas.openxmlformats.org/drawingml/2006/main">
+            <a:off x="552450" y="6515100"/>
+            <a:ext cx="5334000" cy="190500"/>
+          </a:xfrm>
+          <a:prstGeom xmlns:a="http://schemas.openxmlformats.org/drawingml/2006/main" prst="rect">
+            <a:avLst/>
+          </a:prstGeom>
+          <a:solidFill xmlns:a="http://schemas.openxmlformats.org/drawingml/2006/main">
+            <a:srgbClr val="000000">
+              <a:alpha val="0"/>
+            </a:srgbClr>
+          </a:solidFill>
+          <a:ln xmlns:a="http://schemas.openxmlformats.org/drawingml/2006/main" w="0">
+            <a:solidFill>
+              <a:srgbClr val="000000">
+                <a:alpha val="0"/>
+              </a:srgbClr>
+            </a:solidFill>
+            <a:prstDash val="solid"/>
+          </a:ln>
+        </p:spPr>
+        <p:txBody>
+          <a:bodyPr xmlns:a="http://schemas.openxmlformats.org/drawingml/2006/main" lIns="0" tIns="0" rIns="0" bIns="0" anchor="t"/>
+          <a:lstStyle xmlns:a="http://schemas.openxmlformats.org/drawingml/2006/main"/>
+          <a:p xmlns:a="http://schemas.openxmlformats.org/drawingml/2006/main">
+            <a:pPr algn="l">
+              <a:defRPr sz="675" b="0">
+                <a:solidFill>
+                  <a:srgbClr val="8793A3"/>
+                </a:solidFill>
+                <a:latin typeface="Aptos"/>
+                <a:ea typeface="Aptos"/>
+                <a:cs typeface="Aptos"/>
+              </a:defRPr>
+            </a:pPr>
+            <a:r>
+              <a:rPr sz="675" b="0">
+                <a:solidFill>
+                  <a:srgbClr val="8793A3"/>
+                </a:solidFill>
+                <a:latin typeface="Aptos"/>
+                <a:ea typeface="Aptos"/>
+                <a:cs typeface="Aptos"/>
+              </a:rPr>
+              <a:t>NetraShield MVP | Judge Demo | May 2026</a:t>
+            </a:r>
+          </a:p>
+        </p:txBody>
+      </p:sp>
+      <p:sp>
+        <p:nvSpPr>
+          <p:cNvPr id="44" name="">
+            <a:extLst xmlns:a="http://schemas.openxmlformats.org/drawingml/2006/main">
+              <a:ext uri="{FF2B5EF4-FFF2-40B4-BE49-F238E27FC236}">
+                <a16:creationId xmlns:a16="http://schemas.microsoft.com/office/drawing/2014/main" id="{0CDC0CD4-A748-4642-A8D8-8869021D984D}"/>
+              </a:ext>
+            </a:extLst>
+          </p:cNvPr>
+          <p:cNvSpPr>
+            <a:spLocks xmlns:a="http://schemas.openxmlformats.org/drawingml/2006/main" noGrp="1"/>
+          </p:cNvSpPr>
+          <p:nvPr/>
+        </p:nvSpPr>
+        <p:spPr>
+          <a:xfrm xmlns:a="http://schemas.openxmlformats.org/drawingml/2006/main">
+            <a:off x="11315700" y="6515100"/>
+            <a:ext cx="323850" cy="190500"/>
+          </a:xfrm>
+          <a:prstGeom xmlns:a="http://schemas.openxmlformats.org/drawingml/2006/main" prst="rect">
+            <a:avLst/>
+          </a:prstGeom>
+          <a:solidFill xmlns:a="http://schemas.openxmlformats.org/drawingml/2006/main">
+            <a:srgbClr val="000000">
+              <a:alpha val="0"/>
+            </a:srgbClr>
+          </a:solidFill>
+          <a:ln xmlns:a="http://schemas.openxmlformats.org/drawingml/2006/main" w="0">
+            <a:solidFill>
+              <a:srgbClr val="000000">
+                <a:alpha val="0"/>
+              </a:srgbClr>
+            </a:solidFill>
+            <a:prstDash val="solid"/>
+          </a:ln>
+        </p:spPr>
+        <p:txBody>
+          <a:bodyPr xmlns:a="http://schemas.openxmlformats.org/drawingml/2006/main" lIns="0" tIns="0" rIns="0" bIns="0" anchor="t"/>
+          <a:lstStyle xmlns:a="http://schemas.openxmlformats.org/drawingml/2006/main"/>
+          <a:p xmlns:a="http://schemas.openxmlformats.org/drawingml/2006/main">
+            <a:pPr algn="r">
+              <a:defRPr sz="750" b="1">
+                <a:solidFill>
+                  <a:srgbClr val="66758A"/>
+                </a:solidFill>
+                <a:latin typeface="Aptos"/>
+                <a:ea typeface="Aptos"/>
+                <a:cs typeface="Aptos"/>
+              </a:defRPr>
+            </a:pPr>
+            <a:r>
+              <a:rPr sz="750" b="1">
+                <a:solidFill>
+                  <a:srgbClr val="66758A"/>
+                </a:solidFill>
+                <a:latin typeface="Aptos"/>
+                <a:ea typeface="Aptos"/>
+                <a:cs typeface="Aptos"/>
+              </a:rPr>
+              <a:t>14</a:t>
+            </a:r>
+          </a:p>
+        </p:txBody>
+      </p:sp>
+    </p:spTree>
+    <p:extLst>
+      <p:ext uri="{BB962C8B-B14F-4D97-AF65-F5344CB8AC3E}">
+        <p14:creationId xmlns:p14="http://schemas.microsoft.com/office/powerpoint/2010/main" val="1377944594"/>
       </p:ext>
     </p:extLst>
   </p:cSld>
@@ -7529,6 +9838,7 @@
           <a:lstStyle xmlns:a="http://schemas.openxmlformats.org/drawingml/2006/main"/>
           <a:p xmlns:a="http://schemas.openxmlformats.org/drawingml/2006/main">
             <a:pPr algn="l">
+              <a:buNone/>
               <a:defRPr sz="900" b="1">
                 <a:solidFill>
                   <a:srgbClr val="0E9F8F"/>
@@ -7593,6 +9903,7 @@
           <a:lstStyle xmlns:a="http://schemas.openxmlformats.org/drawingml/2006/main"/>
           <a:p xmlns:a="http://schemas.openxmlformats.org/drawingml/2006/main">
             <a:pPr algn="l">
+              <a:buNone/>
               <a:defRPr sz="2400" b="1">
                 <a:solidFill>
                   <a:srgbClr val="111827"/>
@@ -7657,6 +9968,7 @@
           <a:lstStyle xmlns:a="http://schemas.openxmlformats.org/drawingml/2006/main"/>
           <a:p xmlns:a="http://schemas.openxmlformats.org/drawingml/2006/main">
             <a:pPr algn="l">
+              <a:buNone/>
               <a:defRPr sz="1125" b="0">
                 <a:solidFill>
                   <a:srgbClr val="66758A"/>
@@ -7754,6 +10066,7 @@
           <a:lstStyle xmlns:a="http://schemas.openxmlformats.org/drawingml/2006/main"/>
           <a:p xmlns:a="http://schemas.openxmlformats.org/drawingml/2006/main">
             <a:pPr algn="l">
+              <a:buNone/>
               <a:defRPr sz="2250" b="1">
                 <a:solidFill>
                   <a:srgbClr val="D94A4A"/>
@@ -7818,6 +10131,7 @@
           <a:lstStyle xmlns:a="http://schemas.openxmlformats.org/drawingml/2006/main"/>
           <a:p xmlns:a="http://schemas.openxmlformats.org/drawingml/2006/main">
             <a:pPr algn="l">
+              <a:buNone/>
               <a:defRPr sz="825" b="1">
                 <a:solidFill>
                   <a:srgbClr val="526172"/>
@@ -7915,6 +10229,7 @@
           <a:lstStyle xmlns:a="http://schemas.openxmlformats.org/drawingml/2006/main"/>
           <a:p xmlns:a="http://schemas.openxmlformats.org/drawingml/2006/main">
             <a:pPr algn="l">
+              <a:buNone/>
               <a:defRPr sz="2250" b="1">
                 <a:solidFill>
                   <a:srgbClr val="F59E0B"/>
@@ -7979,6 +10294,7 @@
           <a:lstStyle xmlns:a="http://schemas.openxmlformats.org/drawingml/2006/main"/>
           <a:p xmlns:a="http://schemas.openxmlformats.org/drawingml/2006/main">
             <a:pPr algn="l">
+              <a:buNone/>
               <a:defRPr sz="825" b="1">
                 <a:solidFill>
                   <a:srgbClr val="526172"/>
@@ -8076,6 +10392,7 @@
           <a:lstStyle xmlns:a="http://schemas.openxmlformats.org/drawingml/2006/main"/>
           <a:p xmlns:a="http://schemas.openxmlformats.org/drawingml/2006/main">
             <a:pPr algn="l">
+              <a:buNone/>
               <a:defRPr sz="2250" b="1">
                 <a:solidFill>
                   <a:srgbClr val="2F6FED"/>
@@ -8140,6 +10457,7 @@
           <a:lstStyle xmlns:a="http://schemas.openxmlformats.org/drawingml/2006/main"/>
           <a:p xmlns:a="http://schemas.openxmlformats.org/drawingml/2006/main">
             <a:pPr algn="l">
+              <a:buNone/>
               <a:defRPr sz="825" b="1">
                 <a:solidFill>
                   <a:srgbClr val="526172"/>
@@ -8237,6 +10555,7 @@
           <a:lstStyle xmlns:a="http://schemas.openxmlformats.org/drawingml/2006/main"/>
           <a:p xmlns:a="http://schemas.openxmlformats.org/drawingml/2006/main">
             <a:pPr algn="l">
+              <a:buNone/>
               <a:defRPr sz="2250" b="1">
                 <a:solidFill>
                   <a:srgbClr val="6B5DD3"/>
@@ -8301,6 +10620,7 @@
           <a:lstStyle xmlns:a="http://schemas.openxmlformats.org/drawingml/2006/main"/>
           <a:p xmlns:a="http://schemas.openxmlformats.org/drawingml/2006/main">
             <a:pPr algn="l">
+              <a:buNone/>
               <a:defRPr sz="825" b="1">
                 <a:solidFill>
                   <a:srgbClr val="526172"/>
@@ -8431,6 +10751,7 @@
           <a:lstStyle xmlns:a="http://schemas.openxmlformats.org/drawingml/2006/main"/>
           <a:p xmlns:a="http://schemas.openxmlformats.org/drawingml/2006/main">
             <a:pPr algn="l">
+              <a:buNone/>
               <a:defRPr sz="1125" b="1">
                 <a:solidFill>
                   <a:srgbClr val="111827"/>
@@ -8495,6 +10816,7 @@
           <a:lstStyle xmlns:a="http://schemas.openxmlformats.org/drawingml/2006/main"/>
           <a:p xmlns:a="http://schemas.openxmlformats.org/drawingml/2006/main">
             <a:pPr algn="l">
+              <a:buNone/>
               <a:defRPr sz="900" b="0">
                 <a:solidFill>
                   <a:srgbClr val="526172"/>
@@ -8625,6 +10947,7 @@
           <a:lstStyle xmlns:a="http://schemas.openxmlformats.org/drawingml/2006/main"/>
           <a:p xmlns:a="http://schemas.openxmlformats.org/drawingml/2006/main">
             <a:pPr algn="l">
+              <a:buNone/>
               <a:defRPr sz="1125" b="1">
                 <a:solidFill>
                   <a:srgbClr val="111827"/>
@@ -8689,6 +11012,7 @@
           <a:lstStyle xmlns:a="http://schemas.openxmlformats.org/drawingml/2006/main"/>
           <a:p xmlns:a="http://schemas.openxmlformats.org/drawingml/2006/main">
             <a:pPr algn="l">
+              <a:buNone/>
               <a:defRPr sz="900" b="0">
                 <a:solidFill>
                   <a:srgbClr val="526172"/>
@@ -8753,6 +11077,7 @@
           <a:lstStyle xmlns:a="http://schemas.openxmlformats.org/drawingml/2006/main"/>
           <a:p xmlns:a="http://schemas.openxmlformats.org/drawingml/2006/main">
             <a:pPr algn="l">
+              <a:buNone/>
               <a:defRPr sz="675" b="0">
                 <a:solidFill>
                   <a:srgbClr val="8793A3"/>
@@ -8817,6 +11142,7 @@
           <a:lstStyle xmlns:a="http://schemas.openxmlformats.org/drawingml/2006/main"/>
           <a:p xmlns:a="http://schemas.openxmlformats.org/drawingml/2006/main">
             <a:pPr algn="r">
+              <a:buNone/>
               <a:defRPr sz="750" b="1">
                 <a:solidFill>
                   <a:srgbClr val="66758A"/>
@@ -8938,6 +11264,7 @@
           <a:lstStyle xmlns:a="http://schemas.openxmlformats.org/drawingml/2006/main"/>
           <a:p xmlns:a="http://schemas.openxmlformats.org/drawingml/2006/main">
             <a:pPr algn="l">
+              <a:buNone/>
               <a:defRPr sz="900" b="1">
                 <a:solidFill>
                   <a:srgbClr val="0E9F8F"/>
@@ -9002,6 +11329,7 @@
           <a:lstStyle xmlns:a="http://schemas.openxmlformats.org/drawingml/2006/main"/>
           <a:p xmlns:a="http://schemas.openxmlformats.org/drawingml/2006/main">
             <a:pPr algn="l">
+              <a:buNone/>
               <a:defRPr sz="2400" b="1">
                 <a:solidFill>
                   <a:srgbClr val="111827"/>
@@ -9066,6 +11394,7 @@
           <a:lstStyle xmlns:a="http://schemas.openxmlformats.org/drawingml/2006/main"/>
           <a:p xmlns:a="http://schemas.openxmlformats.org/drawingml/2006/main">
             <a:pPr algn="l">
+              <a:buNone/>
               <a:defRPr sz="1125" b="0">
                 <a:solidFill>
                   <a:srgbClr val="66758A"/>
@@ -9163,6 +11492,7 @@
           <a:lstStyle xmlns:a="http://schemas.openxmlformats.org/drawingml/2006/main"/>
           <a:p xmlns:a="http://schemas.openxmlformats.org/drawingml/2006/main">
             <a:pPr algn="l">
+              <a:buNone/>
               <a:defRPr sz="1125" b="0">
                 <a:solidFill>
                   <a:srgbClr val="526172"/>
@@ -9260,6 +11590,7 @@
           <a:lstStyle xmlns:a="http://schemas.openxmlformats.org/drawingml/2006/main"/>
           <a:p xmlns:a="http://schemas.openxmlformats.org/drawingml/2006/main">
             <a:pPr algn="l">
+              <a:buNone/>
               <a:defRPr sz="1125" b="0">
                 <a:solidFill>
                   <a:srgbClr val="526172"/>
@@ -9357,6 +11688,7 @@
           <a:lstStyle xmlns:a="http://schemas.openxmlformats.org/drawingml/2006/main"/>
           <a:p xmlns:a="http://schemas.openxmlformats.org/drawingml/2006/main">
             <a:pPr algn="l">
+              <a:buNone/>
               <a:defRPr sz="1125" b="0">
                 <a:solidFill>
                   <a:srgbClr val="526172"/>
@@ -9454,6 +11786,7 @@
           <a:lstStyle xmlns:a="http://schemas.openxmlformats.org/drawingml/2006/main"/>
           <a:p xmlns:a="http://schemas.openxmlformats.org/drawingml/2006/main">
             <a:pPr algn="l">
+              <a:buNone/>
               <a:defRPr sz="1125" b="0">
                 <a:solidFill>
                   <a:srgbClr val="526172"/>
@@ -9551,6 +11884,7 @@
           <a:lstStyle xmlns:a="http://schemas.openxmlformats.org/drawingml/2006/main"/>
           <a:p xmlns:a="http://schemas.openxmlformats.org/drawingml/2006/main">
             <a:pPr algn="l">
+              <a:buNone/>
               <a:defRPr sz="1350" b="1">
                 <a:solidFill>
                   <a:srgbClr val="111827"/>
@@ -9648,6 +11982,7 @@
           <a:lstStyle xmlns:a="http://schemas.openxmlformats.org/drawingml/2006/main"/>
           <a:p xmlns:a="http://schemas.openxmlformats.org/drawingml/2006/main">
             <a:pPr algn="l">
+              <a:buNone/>
               <a:defRPr sz="1125" b="0">
                 <a:solidFill>
                   <a:srgbClr val="526172"/>
@@ -9745,6 +12080,7 @@
           <a:lstStyle xmlns:a="http://schemas.openxmlformats.org/drawingml/2006/main"/>
           <a:p xmlns:a="http://schemas.openxmlformats.org/drawingml/2006/main">
             <a:pPr algn="l">
+              <a:buNone/>
               <a:defRPr sz="1125" b="0">
                 <a:solidFill>
                   <a:srgbClr val="526172"/>
@@ -9842,6 +12178,7 @@
           <a:lstStyle xmlns:a="http://schemas.openxmlformats.org/drawingml/2006/main"/>
           <a:p xmlns:a="http://schemas.openxmlformats.org/drawingml/2006/main">
             <a:pPr algn="l">
+              <a:buNone/>
               <a:defRPr sz="1125" b="0">
                 <a:solidFill>
                   <a:srgbClr val="526172"/>
@@ -9939,6 +12276,7 @@
           <a:lstStyle xmlns:a="http://schemas.openxmlformats.org/drawingml/2006/main"/>
           <a:p xmlns:a="http://schemas.openxmlformats.org/drawingml/2006/main">
             <a:pPr algn="l">
+              <a:buNone/>
               <a:defRPr sz="1125" b="0">
                 <a:solidFill>
                   <a:srgbClr val="526172"/>
@@ -10036,6 +12374,7 @@
           <a:lstStyle xmlns:a="http://schemas.openxmlformats.org/drawingml/2006/main"/>
           <a:p xmlns:a="http://schemas.openxmlformats.org/drawingml/2006/main">
             <a:pPr algn="l">
+              <a:buNone/>
               <a:defRPr sz="1125" b="0">
                 <a:solidFill>
                   <a:srgbClr val="526172"/>
@@ -10100,6 +12439,7 @@
           <a:lstStyle xmlns:a="http://schemas.openxmlformats.org/drawingml/2006/main"/>
           <a:p xmlns:a="http://schemas.openxmlformats.org/drawingml/2006/main">
             <a:pPr algn="l">
+              <a:buNone/>
               <a:defRPr sz="675" b="0">
                 <a:solidFill>
                   <a:srgbClr val="8793A3"/>
@@ -10164,6 +12504,7 @@
           <a:lstStyle xmlns:a="http://schemas.openxmlformats.org/drawingml/2006/main"/>
           <a:p xmlns:a="http://schemas.openxmlformats.org/drawingml/2006/main">
             <a:pPr algn="r">
+              <a:buNone/>
               <a:defRPr sz="750" b="1">
                 <a:solidFill>
                   <a:srgbClr val="66758A"/>
@@ -10285,6 +12626,7 @@
           <a:lstStyle xmlns:a="http://schemas.openxmlformats.org/drawingml/2006/main"/>
           <a:p xmlns:a="http://schemas.openxmlformats.org/drawingml/2006/main">
             <a:pPr algn="l">
+              <a:buNone/>
               <a:defRPr sz="900" b="1">
                 <a:solidFill>
                   <a:srgbClr val="0E9F8F"/>
@@ -10349,6 +12691,7 @@
           <a:lstStyle xmlns:a="http://schemas.openxmlformats.org/drawingml/2006/main"/>
           <a:p xmlns:a="http://schemas.openxmlformats.org/drawingml/2006/main">
             <a:pPr algn="l">
+              <a:buNone/>
               <a:defRPr sz="2400" b="1">
                 <a:solidFill>
                   <a:srgbClr val="111827"/>
@@ -10413,6 +12756,7 @@
           <a:lstStyle xmlns:a="http://schemas.openxmlformats.org/drawingml/2006/main"/>
           <a:p xmlns:a="http://schemas.openxmlformats.org/drawingml/2006/main">
             <a:pPr algn="l">
+              <a:buNone/>
               <a:defRPr sz="1125" b="0">
                 <a:solidFill>
                   <a:srgbClr val="66758A"/>
@@ -10543,6 +12887,7 @@
           <a:lstStyle xmlns:a="http://schemas.openxmlformats.org/drawingml/2006/main"/>
           <a:p xmlns:a="http://schemas.openxmlformats.org/drawingml/2006/main">
             <a:pPr algn="l">
+              <a:buNone/>
               <a:defRPr sz="1125" b="1">
                 <a:solidFill>
                   <a:srgbClr val="111827"/>
@@ -10607,6 +12952,7 @@
           <a:lstStyle xmlns:a="http://schemas.openxmlformats.org/drawingml/2006/main"/>
           <a:p xmlns:a="http://schemas.openxmlformats.org/drawingml/2006/main">
             <a:pPr algn="l">
+              <a:buNone/>
               <a:defRPr sz="900" b="0">
                 <a:solidFill>
                   <a:srgbClr val="526172"/>
@@ -10737,6 +13083,7 @@
           <a:lstStyle xmlns:a="http://schemas.openxmlformats.org/drawingml/2006/main"/>
           <a:p xmlns:a="http://schemas.openxmlformats.org/drawingml/2006/main">
             <a:pPr algn="l">
+              <a:buNone/>
               <a:defRPr sz="1125" b="1">
                 <a:solidFill>
                   <a:srgbClr val="111827"/>
@@ -10801,6 +13148,7 @@
           <a:lstStyle xmlns:a="http://schemas.openxmlformats.org/drawingml/2006/main"/>
           <a:p xmlns:a="http://schemas.openxmlformats.org/drawingml/2006/main">
             <a:pPr algn="l">
+              <a:buNone/>
               <a:defRPr sz="900" b="0">
                 <a:solidFill>
                   <a:srgbClr val="526172"/>
@@ -10931,6 +13279,7 @@
           <a:lstStyle xmlns:a="http://schemas.openxmlformats.org/drawingml/2006/main"/>
           <a:p xmlns:a="http://schemas.openxmlformats.org/drawingml/2006/main">
             <a:pPr algn="l">
+              <a:buNone/>
               <a:defRPr sz="1125" b="1">
                 <a:solidFill>
                   <a:srgbClr val="111827"/>
@@ -10995,6 +13344,7 @@
           <a:lstStyle xmlns:a="http://schemas.openxmlformats.org/drawingml/2006/main"/>
           <a:p xmlns:a="http://schemas.openxmlformats.org/drawingml/2006/main">
             <a:pPr algn="l">
+              <a:buNone/>
               <a:defRPr sz="900" b="0">
                 <a:solidFill>
                   <a:srgbClr val="526172"/>
@@ -11125,6 +13475,7 @@
           <a:lstStyle xmlns:a="http://schemas.openxmlformats.org/drawingml/2006/main"/>
           <a:p xmlns:a="http://schemas.openxmlformats.org/drawingml/2006/main">
             <a:pPr algn="l">
+              <a:buNone/>
               <a:defRPr sz="1125" b="1">
                 <a:solidFill>
                   <a:srgbClr val="111827"/>
@@ -11189,6 +13540,7 @@
           <a:lstStyle xmlns:a="http://schemas.openxmlformats.org/drawingml/2006/main"/>
           <a:p xmlns:a="http://schemas.openxmlformats.org/drawingml/2006/main">
             <a:pPr algn="l">
+              <a:buNone/>
               <a:defRPr sz="900" b="0">
                 <a:solidFill>
                   <a:srgbClr val="526172"/>
@@ -11319,6 +13671,7 @@
           <a:lstStyle xmlns:a="http://schemas.openxmlformats.org/drawingml/2006/main"/>
           <a:p xmlns:a="http://schemas.openxmlformats.org/drawingml/2006/main">
             <a:pPr algn="l">
+              <a:buNone/>
               <a:defRPr sz="1125" b="1">
                 <a:solidFill>
                   <a:srgbClr val="111827"/>
@@ -11383,6 +13736,7 @@
           <a:lstStyle xmlns:a="http://schemas.openxmlformats.org/drawingml/2006/main"/>
           <a:p xmlns:a="http://schemas.openxmlformats.org/drawingml/2006/main">
             <a:pPr algn="l">
+              <a:buNone/>
               <a:defRPr sz="900" b="0">
                 <a:solidFill>
                   <a:srgbClr val="526172"/>
@@ -11513,6 +13867,7 @@
           <a:lstStyle xmlns:a="http://schemas.openxmlformats.org/drawingml/2006/main"/>
           <a:p xmlns:a="http://schemas.openxmlformats.org/drawingml/2006/main">
             <a:pPr algn="l">
+              <a:buNone/>
               <a:defRPr sz="1125" b="1">
                 <a:solidFill>
                   <a:srgbClr val="111827"/>
@@ -11577,6 +13932,7 @@
           <a:lstStyle xmlns:a="http://schemas.openxmlformats.org/drawingml/2006/main"/>
           <a:p xmlns:a="http://schemas.openxmlformats.org/drawingml/2006/main">
             <a:pPr algn="l">
+              <a:buNone/>
               <a:defRPr sz="900" b="0">
                 <a:solidFill>
                   <a:srgbClr val="526172"/>
@@ -11641,6 +13997,7 @@
           <a:lstStyle xmlns:a="http://schemas.openxmlformats.org/drawingml/2006/main"/>
           <a:p xmlns:a="http://schemas.openxmlformats.org/drawingml/2006/main">
             <a:pPr algn="l">
+              <a:buNone/>
               <a:defRPr sz="675" b="0">
                 <a:solidFill>
                   <a:srgbClr val="8793A3"/>
@@ -11705,6 +14062,7 @@
           <a:lstStyle xmlns:a="http://schemas.openxmlformats.org/drawingml/2006/main"/>
           <a:p xmlns:a="http://schemas.openxmlformats.org/drawingml/2006/main">
             <a:pPr algn="r">
+              <a:buNone/>
               <a:defRPr sz="750" b="1">
                 <a:solidFill>
                   <a:srgbClr val="66758A"/>
@@ -11826,6 +14184,7 @@
           <a:lstStyle xmlns:a="http://schemas.openxmlformats.org/drawingml/2006/main"/>
           <a:p xmlns:a="http://schemas.openxmlformats.org/drawingml/2006/main">
             <a:pPr algn="l">
+              <a:buNone/>
               <a:defRPr sz="900" b="1">
                 <a:solidFill>
                   <a:srgbClr val="0E9F8F"/>
@@ -11890,6 +14249,7 @@
           <a:lstStyle xmlns:a="http://schemas.openxmlformats.org/drawingml/2006/main"/>
           <a:p xmlns:a="http://schemas.openxmlformats.org/drawingml/2006/main">
             <a:pPr algn="l">
+              <a:buNone/>
               <a:defRPr sz="2400" b="1">
                 <a:solidFill>
                   <a:srgbClr val="111827"/>
@@ -11954,6 +14314,7 @@
           <a:lstStyle xmlns:a="http://schemas.openxmlformats.org/drawingml/2006/main"/>
           <a:p xmlns:a="http://schemas.openxmlformats.org/drawingml/2006/main">
             <a:pPr algn="l">
+              <a:buNone/>
               <a:defRPr sz="1125" b="0">
                 <a:solidFill>
                   <a:srgbClr val="66758A"/>
@@ -12051,6 +14412,7 @@
           <a:lstStyle xmlns:a="http://schemas.openxmlformats.org/drawingml/2006/main"/>
           <a:p xmlns:a="http://schemas.openxmlformats.org/drawingml/2006/main">
             <a:pPr algn="ctr">
+              <a:buNone/>
               <a:defRPr sz="900" b="1">
                 <a:solidFill>
                   <a:srgbClr val="FFFFFF"/>
@@ -12181,6 +14543,7 @@
           <a:lstStyle xmlns:a="http://schemas.openxmlformats.org/drawingml/2006/main"/>
           <a:p xmlns:a="http://schemas.openxmlformats.org/drawingml/2006/main">
             <a:pPr algn="ctr">
+              <a:buNone/>
               <a:defRPr sz="900" b="1">
                 <a:solidFill>
                   <a:srgbClr val="FFFFFF"/>
@@ -12311,6 +14674,7 @@
           <a:lstStyle xmlns:a="http://schemas.openxmlformats.org/drawingml/2006/main"/>
           <a:p xmlns:a="http://schemas.openxmlformats.org/drawingml/2006/main">
             <a:pPr algn="ctr">
+              <a:buNone/>
               <a:defRPr sz="900" b="1">
                 <a:solidFill>
                   <a:srgbClr val="FFFFFF"/>
@@ -12441,6 +14805,7 @@
           <a:lstStyle xmlns:a="http://schemas.openxmlformats.org/drawingml/2006/main"/>
           <a:p xmlns:a="http://schemas.openxmlformats.org/drawingml/2006/main">
             <a:pPr algn="ctr">
+              <a:buNone/>
               <a:defRPr sz="900" b="1">
                 <a:solidFill>
                   <a:srgbClr val="FFFFFF"/>
@@ -12571,6 +14936,7 @@
           <a:lstStyle xmlns:a="http://schemas.openxmlformats.org/drawingml/2006/main"/>
           <a:p xmlns:a="http://schemas.openxmlformats.org/drawingml/2006/main">
             <a:pPr algn="ctr">
+              <a:buNone/>
               <a:defRPr sz="900" b="1">
                 <a:solidFill>
                   <a:srgbClr val="FFFFFF"/>
@@ -12701,6 +15067,7 @@
           <a:lstStyle xmlns:a="http://schemas.openxmlformats.org/drawingml/2006/main"/>
           <a:p xmlns:a="http://schemas.openxmlformats.org/drawingml/2006/main">
             <a:pPr algn="ctr">
+              <a:buNone/>
               <a:defRPr sz="900" b="1">
                 <a:solidFill>
                   <a:srgbClr val="FFFFFF"/>
@@ -12831,6 +15198,7 @@
           <a:lstStyle xmlns:a="http://schemas.openxmlformats.org/drawingml/2006/main"/>
           <a:p xmlns:a="http://schemas.openxmlformats.org/drawingml/2006/main">
             <a:pPr algn="ctr">
+              <a:buNone/>
               <a:defRPr sz="900" b="1">
                 <a:solidFill>
                   <a:srgbClr val="FFFFFF"/>
@@ -12961,6 +15329,7 @@
           <a:lstStyle xmlns:a="http://schemas.openxmlformats.org/drawingml/2006/main"/>
           <a:p xmlns:a="http://schemas.openxmlformats.org/drawingml/2006/main">
             <a:pPr algn="l">
+              <a:buNone/>
               <a:defRPr sz="1125" b="1">
                 <a:solidFill>
                   <a:srgbClr val="111827"/>
@@ -13025,6 +15394,7 @@
           <a:lstStyle xmlns:a="http://schemas.openxmlformats.org/drawingml/2006/main"/>
           <a:p xmlns:a="http://schemas.openxmlformats.org/drawingml/2006/main">
             <a:pPr algn="l">
+              <a:buNone/>
               <a:defRPr sz="900" b="0">
                 <a:solidFill>
                   <a:srgbClr val="526172"/>
@@ -13155,6 +15525,7 @@
           <a:lstStyle xmlns:a="http://schemas.openxmlformats.org/drawingml/2006/main"/>
           <a:p xmlns:a="http://schemas.openxmlformats.org/drawingml/2006/main">
             <a:pPr algn="l">
+              <a:buNone/>
               <a:defRPr sz="1125" b="1">
                 <a:solidFill>
                   <a:srgbClr val="111827"/>
@@ -13219,6 +15590,7 @@
           <a:lstStyle xmlns:a="http://schemas.openxmlformats.org/drawingml/2006/main"/>
           <a:p xmlns:a="http://schemas.openxmlformats.org/drawingml/2006/main">
             <a:pPr algn="l">
+              <a:buNone/>
               <a:defRPr sz="900" b="0">
                 <a:solidFill>
                   <a:srgbClr val="526172"/>
@@ -13349,6 +15721,7 @@
           <a:lstStyle xmlns:a="http://schemas.openxmlformats.org/drawingml/2006/main"/>
           <a:p xmlns:a="http://schemas.openxmlformats.org/drawingml/2006/main">
             <a:pPr algn="l">
+              <a:buNone/>
               <a:defRPr sz="1125" b="1">
                 <a:solidFill>
                   <a:srgbClr val="111827"/>
@@ -13413,6 +15786,7 @@
           <a:lstStyle xmlns:a="http://schemas.openxmlformats.org/drawingml/2006/main"/>
           <a:p xmlns:a="http://schemas.openxmlformats.org/drawingml/2006/main">
             <a:pPr algn="l">
+              <a:buNone/>
               <a:defRPr sz="900" b="0">
                 <a:solidFill>
                   <a:srgbClr val="526172"/>
@@ -13477,6 +15851,7 @@
           <a:lstStyle xmlns:a="http://schemas.openxmlformats.org/drawingml/2006/main"/>
           <a:p xmlns:a="http://schemas.openxmlformats.org/drawingml/2006/main">
             <a:pPr algn="l">
+              <a:buNone/>
               <a:defRPr sz="675" b="0">
                 <a:solidFill>
                   <a:srgbClr val="8793A3"/>
@@ -13541,6 +15916,7 @@
           <a:lstStyle xmlns:a="http://schemas.openxmlformats.org/drawingml/2006/main"/>
           <a:p xmlns:a="http://schemas.openxmlformats.org/drawingml/2006/main">
             <a:pPr algn="r">
+              <a:buNone/>
               <a:defRPr sz="750" b="1">
                 <a:solidFill>
                   <a:srgbClr val="66758A"/>
@@ -13662,6 +16038,7 @@
           <a:lstStyle xmlns:a="http://schemas.openxmlformats.org/drawingml/2006/main"/>
           <a:p xmlns:a="http://schemas.openxmlformats.org/drawingml/2006/main">
             <a:pPr algn="l">
+              <a:buNone/>
               <a:defRPr sz="900" b="1">
                 <a:solidFill>
                   <a:srgbClr val="0E9F8F"/>
@@ -13726,6 +16103,7 @@
           <a:lstStyle xmlns:a="http://schemas.openxmlformats.org/drawingml/2006/main"/>
           <a:p xmlns:a="http://schemas.openxmlformats.org/drawingml/2006/main">
             <a:pPr algn="l">
+              <a:buNone/>
               <a:defRPr sz="2400" b="1">
                 <a:solidFill>
                   <a:srgbClr val="111827"/>
@@ -13790,6 +16168,7 @@
           <a:lstStyle xmlns:a="http://schemas.openxmlformats.org/drawingml/2006/main"/>
           <a:p xmlns:a="http://schemas.openxmlformats.org/drawingml/2006/main">
             <a:pPr algn="l">
+              <a:buNone/>
               <a:defRPr sz="1125" b="0">
                 <a:solidFill>
                   <a:srgbClr val="66758A"/>
@@ -13920,6 +16299,7 @@
           <a:lstStyle xmlns:a="http://schemas.openxmlformats.org/drawingml/2006/main"/>
           <a:p xmlns:a="http://schemas.openxmlformats.org/drawingml/2006/main">
             <a:pPr algn="l">
+              <a:buNone/>
               <a:defRPr sz="1125" b="1">
                 <a:solidFill>
                   <a:srgbClr val="111827"/>
@@ -13984,6 +16364,7 @@
           <a:lstStyle xmlns:a="http://schemas.openxmlformats.org/drawingml/2006/main"/>
           <a:p xmlns:a="http://schemas.openxmlformats.org/drawingml/2006/main">
             <a:pPr algn="l">
+              <a:buNone/>
               <a:defRPr sz="900" b="0">
                 <a:solidFill>
                   <a:srgbClr val="526172"/>
@@ -14114,6 +16495,7 @@
           <a:lstStyle xmlns:a="http://schemas.openxmlformats.org/drawingml/2006/main"/>
           <a:p xmlns:a="http://schemas.openxmlformats.org/drawingml/2006/main">
             <a:pPr algn="l">
+              <a:buNone/>
               <a:defRPr sz="1125" b="1">
                 <a:solidFill>
                   <a:srgbClr val="111827"/>
@@ -14178,6 +16560,7 @@
           <a:lstStyle xmlns:a="http://schemas.openxmlformats.org/drawingml/2006/main"/>
           <a:p xmlns:a="http://schemas.openxmlformats.org/drawingml/2006/main">
             <a:pPr algn="l">
+              <a:buNone/>
               <a:defRPr sz="900" b="0">
                 <a:solidFill>
                   <a:srgbClr val="526172"/>
@@ -14308,6 +16691,7 @@
           <a:lstStyle xmlns:a="http://schemas.openxmlformats.org/drawingml/2006/main"/>
           <a:p xmlns:a="http://schemas.openxmlformats.org/drawingml/2006/main">
             <a:pPr algn="l">
+              <a:buNone/>
               <a:defRPr sz="1125" b="1">
                 <a:solidFill>
                   <a:srgbClr val="111827"/>
@@ -14372,6 +16756,7 @@
           <a:lstStyle xmlns:a="http://schemas.openxmlformats.org/drawingml/2006/main"/>
           <a:p xmlns:a="http://schemas.openxmlformats.org/drawingml/2006/main">
             <a:pPr algn="l">
+              <a:buNone/>
               <a:defRPr sz="900" b="0">
                 <a:solidFill>
                   <a:srgbClr val="526172"/>
@@ -14502,6 +16887,7 @@
           <a:lstStyle xmlns:a="http://schemas.openxmlformats.org/drawingml/2006/main"/>
           <a:p xmlns:a="http://schemas.openxmlformats.org/drawingml/2006/main">
             <a:pPr algn="l">
+              <a:buNone/>
               <a:defRPr sz="1125" b="1">
                 <a:solidFill>
                   <a:srgbClr val="111827"/>
@@ -14566,6 +16952,7 @@
           <a:lstStyle xmlns:a="http://schemas.openxmlformats.org/drawingml/2006/main"/>
           <a:p xmlns:a="http://schemas.openxmlformats.org/drawingml/2006/main">
             <a:pPr algn="l">
+              <a:buNone/>
               <a:defRPr sz="900" b="0">
                 <a:solidFill>
                   <a:srgbClr val="526172"/>
@@ -14696,6 +17083,7 @@
           <a:lstStyle xmlns:a="http://schemas.openxmlformats.org/drawingml/2006/main"/>
           <a:p xmlns:a="http://schemas.openxmlformats.org/drawingml/2006/main">
             <a:pPr algn="l">
+              <a:buNone/>
               <a:defRPr sz="1125" b="1">
                 <a:solidFill>
                   <a:srgbClr val="111827"/>
@@ -14760,6 +17148,7 @@
           <a:lstStyle xmlns:a="http://schemas.openxmlformats.org/drawingml/2006/main"/>
           <a:p xmlns:a="http://schemas.openxmlformats.org/drawingml/2006/main">
             <a:pPr algn="l">
+              <a:buNone/>
               <a:defRPr sz="900" b="0">
                 <a:solidFill>
                   <a:srgbClr val="526172"/>
@@ -14890,6 +17279,7 @@
           <a:lstStyle xmlns:a="http://schemas.openxmlformats.org/drawingml/2006/main"/>
           <a:p xmlns:a="http://schemas.openxmlformats.org/drawingml/2006/main">
             <a:pPr algn="l">
+              <a:buNone/>
               <a:defRPr sz="825" b="1">
                 <a:solidFill>
                   <a:srgbClr val="526172"/>
@@ -15020,6 +17410,7 @@
           <a:lstStyle xmlns:a="http://schemas.openxmlformats.org/drawingml/2006/main"/>
           <a:p xmlns:a="http://schemas.openxmlformats.org/drawingml/2006/main">
             <a:pPr algn="l">
+              <a:buNone/>
               <a:defRPr sz="825" b="1">
                 <a:solidFill>
                   <a:srgbClr val="526172"/>
@@ -15150,6 +17541,7 @@
           <a:lstStyle xmlns:a="http://schemas.openxmlformats.org/drawingml/2006/main"/>
           <a:p xmlns:a="http://schemas.openxmlformats.org/drawingml/2006/main">
             <a:pPr algn="l">
+              <a:buNone/>
               <a:defRPr sz="825" b="1">
                 <a:solidFill>
                   <a:srgbClr val="526172"/>
@@ -15214,6 +17606,7 @@
           <a:lstStyle xmlns:a="http://schemas.openxmlformats.org/drawingml/2006/main"/>
           <a:p xmlns:a="http://schemas.openxmlformats.org/drawingml/2006/main">
             <a:pPr algn="l">
+              <a:buNone/>
               <a:defRPr sz="1500" b="1">
                 <a:solidFill>
                   <a:srgbClr val="111827"/>
@@ -15278,6 +17671,7 @@
           <a:lstStyle xmlns:a="http://schemas.openxmlformats.org/drawingml/2006/main"/>
           <a:p xmlns:a="http://schemas.openxmlformats.org/drawingml/2006/main">
             <a:pPr algn="l">
+              <a:buNone/>
               <a:defRPr sz="675" b="0">
                 <a:solidFill>
                   <a:srgbClr val="8793A3"/>
@@ -15342,6 +17736,7 @@
           <a:lstStyle xmlns:a="http://schemas.openxmlformats.org/drawingml/2006/main"/>
           <a:p xmlns:a="http://schemas.openxmlformats.org/drawingml/2006/main">
             <a:pPr algn="r">
+              <a:buNone/>
               <a:defRPr sz="750" b="1">
                 <a:solidFill>
                   <a:srgbClr val="66758A"/>
@@ -15463,6 +17858,7 @@
           <a:lstStyle xmlns:a="http://schemas.openxmlformats.org/drawingml/2006/main"/>
           <a:p xmlns:a="http://schemas.openxmlformats.org/drawingml/2006/main">
             <a:pPr algn="l">
+              <a:buNone/>
               <a:defRPr sz="900" b="1">
                 <a:solidFill>
                   <a:srgbClr val="0E9F8F"/>
@@ -15527,6 +17923,7 @@
           <a:lstStyle xmlns:a="http://schemas.openxmlformats.org/drawingml/2006/main"/>
           <a:p xmlns:a="http://schemas.openxmlformats.org/drawingml/2006/main">
             <a:pPr algn="l">
+              <a:buNone/>
               <a:defRPr sz="2400" b="1">
                 <a:solidFill>
                   <a:srgbClr val="111827"/>
@@ -15591,6 +17988,7 @@
           <a:lstStyle xmlns:a="http://schemas.openxmlformats.org/drawingml/2006/main"/>
           <a:p xmlns:a="http://schemas.openxmlformats.org/drawingml/2006/main">
             <a:pPr algn="l">
+              <a:buNone/>
               <a:defRPr sz="1125" b="0">
                 <a:solidFill>
                   <a:srgbClr val="66758A"/>
@@ -15688,6 +18086,7 @@
           <a:lstStyle xmlns:a="http://schemas.openxmlformats.org/drawingml/2006/main"/>
           <a:p xmlns:a="http://schemas.openxmlformats.org/drawingml/2006/main">
             <a:pPr algn="l">
+              <a:buNone/>
               <a:defRPr sz="1125" b="0">
                 <a:solidFill>
                   <a:srgbClr val="526172"/>
@@ -15785,6 +18184,7 @@
           <a:lstStyle xmlns:a="http://schemas.openxmlformats.org/drawingml/2006/main"/>
           <a:p xmlns:a="http://schemas.openxmlformats.org/drawingml/2006/main">
             <a:pPr algn="l">
+              <a:buNone/>
               <a:defRPr sz="1125" b="0">
                 <a:solidFill>
                   <a:srgbClr val="526172"/>
@@ -15882,6 +18282,7 @@
           <a:lstStyle xmlns:a="http://schemas.openxmlformats.org/drawingml/2006/main"/>
           <a:p xmlns:a="http://schemas.openxmlformats.org/drawingml/2006/main">
             <a:pPr algn="l">
+              <a:buNone/>
               <a:defRPr sz="1125" b="0">
                 <a:solidFill>
                   <a:srgbClr val="526172"/>
@@ -15979,6 +18380,7 @@
           <a:lstStyle xmlns:a="http://schemas.openxmlformats.org/drawingml/2006/main"/>
           <a:p xmlns:a="http://schemas.openxmlformats.org/drawingml/2006/main">
             <a:pPr algn="l">
+              <a:buNone/>
               <a:defRPr sz="1125" b="0">
                 <a:solidFill>
                   <a:srgbClr val="526172"/>
@@ -16076,6 +18478,7 @@
           <a:lstStyle xmlns:a="http://schemas.openxmlformats.org/drawingml/2006/main"/>
           <a:p xmlns:a="http://schemas.openxmlformats.org/drawingml/2006/main">
             <a:pPr algn="l">
+              <a:buNone/>
               <a:defRPr sz="1125" b="0">
                 <a:solidFill>
                   <a:srgbClr val="526172"/>
@@ -16173,6 +18576,7 @@
           <a:lstStyle xmlns:a="http://schemas.openxmlformats.org/drawingml/2006/main"/>
           <a:p xmlns:a="http://schemas.openxmlformats.org/drawingml/2006/main">
             <a:pPr algn="l">
+              <a:buNone/>
               <a:defRPr sz="1125" b="0">
                 <a:solidFill>
                   <a:srgbClr val="526172"/>
@@ -16270,6 +18674,7 @@
           <a:lstStyle xmlns:a="http://schemas.openxmlformats.org/drawingml/2006/main"/>
           <a:p xmlns:a="http://schemas.openxmlformats.org/drawingml/2006/main">
             <a:pPr algn="l">
+              <a:buNone/>
               <a:defRPr sz="1125" b="0">
                 <a:solidFill>
                   <a:srgbClr val="526172"/>
@@ -16367,6 +18772,7 @@
           <a:lstStyle xmlns:a="http://schemas.openxmlformats.org/drawingml/2006/main"/>
           <a:p xmlns:a="http://schemas.openxmlformats.org/drawingml/2006/main">
             <a:pPr algn="l">
+              <a:buNone/>
               <a:defRPr sz="1125" b="0">
                 <a:solidFill>
                   <a:srgbClr val="526172"/>
@@ -16464,6 +18870,7 @@
           <a:lstStyle xmlns:a="http://schemas.openxmlformats.org/drawingml/2006/main"/>
           <a:p xmlns:a="http://schemas.openxmlformats.org/drawingml/2006/main">
             <a:pPr algn="l">
+              <a:buNone/>
               <a:defRPr sz="1125" b="0">
                 <a:solidFill>
                   <a:srgbClr val="526172"/>
@@ -16627,6 +19034,7 @@
           <a:lstStyle xmlns:a="http://schemas.openxmlformats.org/drawingml/2006/main"/>
           <a:p xmlns:a="http://schemas.openxmlformats.org/drawingml/2006/main">
             <a:pPr algn="ctr">
+              <a:buNone/>
               <a:defRPr sz="1650" b="1">
                 <a:solidFill>
                   <a:srgbClr val="111827"/>
@@ -16691,6 +19099,7 @@
           <a:lstStyle xmlns:a="http://schemas.openxmlformats.org/drawingml/2006/main"/>
           <a:p xmlns:a="http://schemas.openxmlformats.org/drawingml/2006/main">
             <a:pPr algn="ctr">
+              <a:buNone/>
               <a:defRPr sz="750" b="1">
                 <a:solidFill>
                   <a:srgbClr val="66758A"/>
@@ -16755,6 +19164,7 @@
           <a:lstStyle xmlns:a="http://schemas.openxmlformats.org/drawingml/2006/main"/>
           <a:p xmlns:a="http://schemas.openxmlformats.org/drawingml/2006/main">
             <a:pPr algn="ctr">
+              <a:buNone/>
               <a:defRPr sz="975" b="0">
                 <a:solidFill>
                   <a:srgbClr val="66758A"/>
@@ -16819,6 +19229,7 @@
           <a:lstStyle xmlns:a="http://schemas.openxmlformats.org/drawingml/2006/main"/>
           <a:p xmlns:a="http://schemas.openxmlformats.org/drawingml/2006/main">
             <a:pPr algn="l">
+              <a:buNone/>
               <a:defRPr sz="675" b="0">
                 <a:solidFill>
                   <a:srgbClr val="8793A3"/>
@@ -16883,6 +19294,7 @@
           <a:lstStyle xmlns:a="http://schemas.openxmlformats.org/drawingml/2006/main"/>
           <a:p xmlns:a="http://schemas.openxmlformats.org/drawingml/2006/main">
             <a:pPr algn="r">
+              <a:buNone/>
               <a:defRPr sz="750" b="1">
                 <a:solidFill>
                   <a:srgbClr val="66758A"/>
@@ -17004,6 +19416,7 @@
           <a:lstStyle xmlns:a="http://schemas.openxmlformats.org/drawingml/2006/main"/>
           <a:p xmlns:a="http://schemas.openxmlformats.org/drawingml/2006/main">
             <a:pPr algn="l">
+              <a:buNone/>
               <a:defRPr sz="900" b="1">
                 <a:solidFill>
                   <a:srgbClr val="0E9F8F"/>
@@ -17068,6 +19481,7 @@
           <a:lstStyle xmlns:a="http://schemas.openxmlformats.org/drawingml/2006/main"/>
           <a:p xmlns:a="http://schemas.openxmlformats.org/drawingml/2006/main">
             <a:pPr algn="l">
+              <a:buNone/>
               <a:defRPr sz="2400" b="1">
                 <a:solidFill>
                   <a:srgbClr val="111827"/>
@@ -17132,6 +19546,7 @@
           <a:lstStyle xmlns:a="http://schemas.openxmlformats.org/drawingml/2006/main"/>
           <a:p xmlns:a="http://schemas.openxmlformats.org/drawingml/2006/main">
             <a:pPr algn="l">
+              <a:buNone/>
               <a:defRPr sz="1125" b="0">
                 <a:solidFill>
                   <a:srgbClr val="66758A"/>
@@ -17229,6 +19644,7 @@
           <a:lstStyle xmlns:a="http://schemas.openxmlformats.org/drawingml/2006/main"/>
           <a:p xmlns:a="http://schemas.openxmlformats.org/drawingml/2006/main">
             <a:pPr algn="l">
+              <a:buNone/>
               <a:defRPr sz="2250" b="1">
                 <a:solidFill>
                   <a:srgbClr val="0E9F8F"/>
@@ -17293,6 +19709,7 @@
           <a:lstStyle xmlns:a="http://schemas.openxmlformats.org/drawingml/2006/main"/>
           <a:p xmlns:a="http://schemas.openxmlformats.org/drawingml/2006/main">
             <a:pPr algn="l">
+              <a:buNone/>
               <a:defRPr sz="825" b="1">
                 <a:solidFill>
                   <a:srgbClr val="526172"/>
@@ -17390,6 +19807,7 @@
           <a:lstStyle xmlns:a="http://schemas.openxmlformats.org/drawingml/2006/main"/>
           <a:p xmlns:a="http://schemas.openxmlformats.org/drawingml/2006/main">
             <a:pPr algn="l">
+              <a:buNone/>
               <a:defRPr sz="2250" b="1">
                 <a:solidFill>
                   <a:srgbClr val="2F6FED"/>
@@ -17454,6 +19872,7 @@
           <a:lstStyle xmlns:a="http://schemas.openxmlformats.org/drawingml/2006/main"/>
           <a:p xmlns:a="http://schemas.openxmlformats.org/drawingml/2006/main">
             <a:pPr algn="l">
+              <a:buNone/>
               <a:defRPr sz="825" b="1">
                 <a:solidFill>
                   <a:srgbClr val="526172"/>
@@ -17551,6 +19970,7 @@
           <a:lstStyle xmlns:a="http://schemas.openxmlformats.org/drawingml/2006/main"/>
           <a:p xmlns:a="http://schemas.openxmlformats.org/drawingml/2006/main">
             <a:pPr algn="l">
+              <a:buNone/>
               <a:defRPr sz="2250" b="1">
                 <a:solidFill>
                   <a:srgbClr val="22A06B"/>
@@ -17615,6 +20035,7 @@
           <a:lstStyle xmlns:a="http://schemas.openxmlformats.org/drawingml/2006/main"/>
           <a:p xmlns:a="http://schemas.openxmlformats.org/drawingml/2006/main">
             <a:pPr algn="l">
+              <a:buNone/>
               <a:defRPr sz="825" b="1">
                 <a:solidFill>
                   <a:srgbClr val="526172"/>
@@ -17712,6 +20133,7 @@
           <a:lstStyle xmlns:a="http://schemas.openxmlformats.org/drawingml/2006/main"/>
           <a:p xmlns:a="http://schemas.openxmlformats.org/drawingml/2006/main">
             <a:pPr algn="l">
+              <a:buNone/>
               <a:defRPr sz="2250" b="1">
                 <a:solidFill>
                   <a:srgbClr val="F59E0B"/>
@@ -17776,6 +20198,7 @@
           <a:lstStyle xmlns:a="http://schemas.openxmlformats.org/drawingml/2006/main"/>
           <a:p xmlns:a="http://schemas.openxmlformats.org/drawingml/2006/main">
             <a:pPr algn="l">
+              <a:buNone/>
               <a:defRPr sz="825" b="1">
                 <a:solidFill>
                   <a:srgbClr val="526172"/>
@@ -17873,6 +20296,7 @@
           <a:lstStyle xmlns:a="http://schemas.openxmlformats.org/drawingml/2006/main"/>
           <a:p xmlns:a="http://schemas.openxmlformats.org/drawingml/2006/main">
             <a:pPr algn="l">
+              <a:buNone/>
               <a:defRPr sz="1350" b="1">
                 <a:solidFill>
                   <a:srgbClr val="111827"/>
@@ -17937,6 +20361,7 @@
           <a:lstStyle xmlns:a="http://schemas.openxmlformats.org/drawingml/2006/main"/>
           <a:p xmlns:a="http://schemas.openxmlformats.org/drawingml/2006/main">
             <a:pPr algn="l">
+              <a:buNone/>
               <a:defRPr sz="1125" b="0">
                 <a:solidFill>
                   <a:srgbClr val="526172"/>
@@ -18001,6 +20426,7 @@
           <a:lstStyle xmlns:a="http://schemas.openxmlformats.org/drawingml/2006/main"/>
           <a:p xmlns:a="http://schemas.openxmlformats.org/drawingml/2006/main">
             <a:pPr algn="l">
+              <a:buNone/>
               <a:defRPr sz="750" b="0">
                 <a:solidFill>
                   <a:srgbClr val="66758A"/>
@@ -18065,6 +20491,7 @@
           <a:lstStyle xmlns:a="http://schemas.openxmlformats.org/drawingml/2006/main"/>
           <a:p xmlns:a="http://schemas.openxmlformats.org/drawingml/2006/main">
             <a:pPr algn="l">
+              <a:buNone/>
               <a:defRPr sz="675" b="0">
                 <a:solidFill>
                   <a:srgbClr val="8793A3"/>
@@ -18129,6 +20556,7 @@
           <a:lstStyle xmlns:a="http://schemas.openxmlformats.org/drawingml/2006/main"/>
           <a:p xmlns:a="http://schemas.openxmlformats.org/drawingml/2006/main">
             <a:pPr algn="r">
+              <a:buNone/>
               <a:defRPr sz="750" b="1">
                 <a:solidFill>
                   <a:srgbClr val="66758A"/>
@@ -18250,6 +20678,7 @@
           <a:lstStyle xmlns:a="http://schemas.openxmlformats.org/drawingml/2006/main"/>
           <a:p xmlns:a="http://schemas.openxmlformats.org/drawingml/2006/main">
             <a:pPr algn="l">
+              <a:buNone/>
               <a:defRPr sz="900" b="1">
                 <a:solidFill>
                   <a:srgbClr val="0E9F8F"/>
@@ -18314,6 +20743,7 @@
           <a:lstStyle xmlns:a="http://schemas.openxmlformats.org/drawingml/2006/main"/>
           <a:p xmlns:a="http://schemas.openxmlformats.org/drawingml/2006/main">
             <a:pPr algn="l">
+              <a:buNone/>
               <a:defRPr sz="2400" b="1">
                 <a:solidFill>
                   <a:srgbClr val="111827"/>
@@ -18378,6 +20808,7 @@
           <a:lstStyle xmlns:a="http://schemas.openxmlformats.org/drawingml/2006/main"/>
           <a:p xmlns:a="http://schemas.openxmlformats.org/drawingml/2006/main">
             <a:pPr algn="l">
+              <a:buNone/>
               <a:defRPr sz="1125" b="0">
                 <a:solidFill>
                   <a:srgbClr val="66758A"/>
@@ -18508,6 +20939,7 @@
           <a:lstStyle xmlns:a="http://schemas.openxmlformats.org/drawingml/2006/main"/>
           <a:p xmlns:a="http://schemas.openxmlformats.org/drawingml/2006/main">
             <a:pPr algn="l">
+              <a:buNone/>
               <a:defRPr sz="1125" b="1">
                 <a:solidFill>
                   <a:srgbClr val="111827"/>
@@ -18572,6 +21004,7 @@
           <a:lstStyle xmlns:a="http://schemas.openxmlformats.org/drawingml/2006/main"/>
           <a:p xmlns:a="http://schemas.openxmlformats.org/drawingml/2006/main">
             <a:pPr algn="l">
+              <a:buNone/>
               <a:defRPr sz="900" b="0">
                 <a:solidFill>
                   <a:srgbClr val="526172"/>
@@ -18702,6 +21135,7 @@
           <a:lstStyle xmlns:a="http://schemas.openxmlformats.org/drawingml/2006/main"/>
           <a:p xmlns:a="http://schemas.openxmlformats.org/drawingml/2006/main">
             <a:pPr algn="l">
+              <a:buNone/>
               <a:defRPr sz="1125" b="1">
                 <a:solidFill>
                   <a:srgbClr val="111827"/>
@@ -18766,6 +21200,7 @@
           <a:lstStyle xmlns:a="http://schemas.openxmlformats.org/drawingml/2006/main"/>
           <a:p xmlns:a="http://schemas.openxmlformats.org/drawingml/2006/main">
             <a:pPr algn="l">
+              <a:buNone/>
               <a:defRPr sz="900" b="0">
                 <a:solidFill>
                   <a:srgbClr val="526172"/>
@@ -18896,6 +21331,7 @@
           <a:lstStyle xmlns:a="http://schemas.openxmlformats.org/drawingml/2006/main"/>
           <a:p xmlns:a="http://schemas.openxmlformats.org/drawingml/2006/main">
             <a:pPr algn="l">
+              <a:buNone/>
               <a:defRPr sz="1125" b="1">
                 <a:solidFill>
                   <a:srgbClr val="111827"/>
@@ -18960,6 +21396,7 @@
           <a:lstStyle xmlns:a="http://schemas.openxmlformats.org/drawingml/2006/main"/>
           <a:p xmlns:a="http://schemas.openxmlformats.org/drawingml/2006/main">
             <a:pPr algn="l">
+              <a:buNone/>
               <a:defRPr sz="900" b="0">
                 <a:solidFill>
                   <a:srgbClr val="526172"/>
@@ -19057,6 +21494,7 @@
           <a:lstStyle xmlns:a="http://schemas.openxmlformats.org/drawingml/2006/main"/>
           <a:p xmlns:a="http://schemas.openxmlformats.org/drawingml/2006/main">
             <a:pPr algn="ctr">
+              <a:buNone/>
               <a:defRPr sz="1425" b="1">
                 <a:solidFill>
                   <a:srgbClr val="111827"/>
@@ -19121,6 +21559,7 @@
           <a:lstStyle xmlns:a="http://schemas.openxmlformats.org/drawingml/2006/main"/>
           <a:p xmlns:a="http://schemas.openxmlformats.org/drawingml/2006/main">
             <a:pPr algn="l">
+              <a:buNone/>
               <a:defRPr sz="675" b="0">
                 <a:solidFill>
                   <a:srgbClr val="8793A3"/>
@@ -19185,6 +21624,7 @@
           <a:lstStyle xmlns:a="http://schemas.openxmlformats.org/drawingml/2006/main"/>
           <a:p xmlns:a="http://schemas.openxmlformats.org/drawingml/2006/main">
             <a:pPr algn="r">
+              <a:buNone/>
               <a:defRPr sz="750" b="1">
                 <a:solidFill>
                   <a:srgbClr val="66758A"/>

</xml_diff>